<commit_message>
S1-CL3: realign all 8 delivery decks to the AT1/AT2/AT3 workbooks; re-cut topics 2-3 to workbook order
Co-Authored-By: Claude Fable 5 <noreply@anthropic.com>
</commit_message>
<xml_diff>
--- a/S1-CL3-Cloud-Infrastructure-Improvement/delivery/topic_05/Topic_05_Slides.pptx
+++ b/S1-CL3-Cloud-Infrastructure-Improvement/delivery/topic_05/Topic_05_Slides.pptx
@@ -22,6 +22,7 @@
     <p:sldId id="270" r:id="rId22"/>
     <p:sldId id="271" r:id="rId23"/>
     <p:sldId id="272" r:id="rId24"/>
+    <p:sldId id="273" r:id="rId25"/>
   </p:sldIdLst>
   <p:sldSz cx="12191695" cy="6858000" type="screen4x3"/>
   <p:notesSz cx="6858000" cy="9144000"/>
@@ -518,87 +519,12 @@
           <a:lstStyle/>
           <a:p>
             <a:r>
-              <a:t>Frame Topic 5 as the pivot into AT2 — AT1 was the design; AT2 is LEADERSHIP evidence. Set the</a:t>
-            </a:r>
-          </a:p>
-          <a:p>
-            <a:r>
-              <a:t>vehicle; don't teach team-planning yet.</a:t>
-            </a:r>
-          </a:p>
-          <a:p>
-            <a:r>
-              <a:t>• First bullet: the approved design is written as CloudFormation by a TEAM OF FOUR, one IaC component</a:t>
-            </a:r>
-          </a:p>
-          <a:p>
-            <a:r>
-              <a:t>each — network, compute, database, storage. That division is the whole set-up.</a:t>
-            </a:r>
-          </a:p>
-          <a:p>
-            <a:r>
-              <a:t>• Second bullet (the key framing): dividing the write is the LEADERSHIP VEHICLE — you plan the team,</a:t>
-            </a:r>
-          </a:p>
-          <a:p>
-            <a:r>
-              <a:t>set expectations, allocate the work. The CloudFormation write itself is a 504 concern and is NOT</a:t>
-            </a:r>
-          </a:p>
-          <a:p>
-            <a:r>
-              <a:t>assessed here; what's marked is how you lead.</a:t>
-            </a:r>
-          </a:p>
-          <a:p>
-            <a:r>
-              <a:t>• Third bullet: this Topic is the SET-UP half of AT2 (plan and stand up the team); leading them</a:t>
-            </a:r>
-          </a:p>
-          <a:p>
-            <a:r>
-              <a:t>through the write is Topic 6.</a:t>
-            </a:r>
-          </a:p>
-          <a:p>
-            <a:r>
-              <a:t>• Fourth bullet: in-world the team is YAT ICT staff improving Ledgerline — keep it concrete.</a:t>
-            </a:r>
-          </a:p>
-          <a:p>
-            <a:r>
-              <a:t>Misconception to pre-empt: "this is a CloudFormation topic." No — the code is the vehicle; the</a:t>
-            </a:r>
-          </a:p>
-          <a:p>
-            <a:r>
-              <a:t>assessed evidence is the team plan, allocation and facilitation (BSBXTW401 el 1–2). Nobody is marked</a:t>
-            </a:r>
-          </a:p>
-          <a:p>
-            <a:r>
-              <a:t>on their template here.</a:t>
-            </a:r>
-          </a:p>
-          <a:p>
-            <a:r>
-              <a:t>Question to pose: "If the four of you each write one component, what's the single biggest risk — and</a:t>
-            </a:r>
-          </a:p>
-          <a:p>
-            <a:r>
-              <a:t>whose job is it to manage it?" (the components don't integrate; the team leader's).</a:t>
-            </a:r>
-          </a:p>
-          <a:p>
-            <a:r>
-              <a:t>UoC/AT2 tie: opens the AT2 leadership arc — BSBXTW401 el 1–2 (plan + coordinate the team); everything</a:t>
-            </a:r>
-          </a:p>
-          <a:p>
-            <a:r>
-              <a:t>today feeds the team plan, allocation records and facilitated set-up evidenced in AT2.</a:t>
+              <a:t>Workbook tasks 1 to 6 today — the whole team set-up, in order.</a:t>
+            </a:r>
+          </a:p>
+          <a:p>
+            <a:r>
+              <a:t>Misconception: this is a CloudFormation topic. The code is the vehicle; the leadership evidence is what's assessed.</a:t>
             </a:r>
           </a:p>
         </p:txBody>
@@ -668,82 +594,12 @@
           <a:lstStyle/>
           <a:p>
             <a:r>
-              <a:t>Second half of Section 4 — inclusion and reaching BEYOND the team. This is where KE 7 and PC 2.4 land.</a:t>
-            </a:r>
-          </a:p>
-          <a:p>
-            <a:r>
-              <a:t>• First bullet: consider the needs of members from diverse backgrounds — apply cross-cultural</a:t>
-            </a:r>
-          </a:p>
-          <a:p>
-            <a:r>
-              <a:t>communication principles and accommodate special needs or disabilities (KE 7, PC 2.3). Facilitation</a:t>
-            </a:r>
-          </a:p>
-          <a:p>
-            <a:r>
-              <a:t>has to work for everyone in the room.</a:t>
-            </a:r>
-          </a:p>
-          <a:p>
-            <a:r>
-              <a:t>• Second bullet: identify opportunities for CROSS-COLLABORATION with internal and external teams</a:t>
-            </a:r>
-          </a:p>
-          <a:p>
-            <a:r>
-              <a:t>(PC 2.4) — the DBA team, the security reviewers, an external CloudFormation SME. The four-person team</a:t>
-            </a:r>
-          </a:p>
-          <a:p>
-            <a:r>
-              <a:t>isn't an island.</a:t>
-            </a:r>
-          </a:p>
-          <a:p>
-            <a:r>
-              <a:t>• Third bullet: respectful, inclusive facilitation is what makes a four-person split behave as one</a:t>
-            </a:r>
-          </a:p>
-          <a:p>
-            <a:r>
-              <a:t>team — it's the enabler, not a nicety.</a:t>
-            </a:r>
-          </a:p>
-          <a:p>
-            <a:r>
-              <a:t>Misconception to pre-empt: "cross-collaboration is just delegating outside." No — PC 2.4 is about</a:t>
-            </a:r>
-          </a:p>
-          <a:p>
-            <a:r>
-              <a:t>identifying where OTHER teams (internal or external) add value to your build; naming those</a:t>
-            </a:r>
-          </a:p>
-          <a:p>
-            <a:r>
-              <a:t>opportunities is the assessed act.</a:t>
-            </a:r>
-          </a:p>
-          <a:p>
-            <a:r>
-              <a:t>Question to pose: "Which internal or external team would you pull in for the database component, and</a:t>
-            </a:r>
-          </a:p>
-          <a:p>
-            <a:r>
-              <a:t>what would you go to them for?" (draws out a concrete PC 2.4 opportunity).</a:t>
-            </a:r>
-          </a:p>
-          <a:p>
-            <a:r>
-              <a:t>UoC/AT2 tie: BSBXTW401 PC 2.3 + PC 2.4 + KE 7 (diverse-background collaboration; cross-collaboration</a:t>
-            </a:r>
-          </a:p>
-          <a:p>
-            <a:r>
-              <a:t>with internal/external teams) → the facilitated, inclusive set-up evidenced in AT2.</a:t>
+              <a:t>Activity = practice workbook tasks 5–6, as the practice team.</a:t>
+            </a:r>
+          </a:p>
+          <a:p>
+            <a:r>
+              <a:t>Press the seams: what must the network owner expose to the compute owner? And press a concrete outside connection, named, with a reason.</a:t>
             </a:r>
           </a:p>
         </p:txBody>
@@ -813,72 +669,12 @@
           <a:lstStyle/>
           <a:p>
             <a:r>
-              <a:t>Open Section 1. Teach that a team pulls together only when its common objective is NAMED and shared —</a:t>
-            </a:r>
-          </a:p>
-          <a:p>
-            <a:r>
-              <a:t>start there.</a:t>
-            </a:r>
-          </a:p>
-          <a:p>
-            <a:r>
-              <a:t>• First bullet: name the common objective out loud — deliver the approved Ledgerline design as</a:t>
-            </a:r>
-          </a:p>
-          <a:p>
-            <a:r>
-              <a:t>working, deployed IaC. Everyone should be able to recite it.</a:t>
-            </a:r>
-          </a:p>
-          <a:p>
-            <a:r>
-              <a:t>• Second bullet: break the objective into RESPONSIBILITIES and required OUTCOMES — what the team must</a:t>
-            </a:r>
-          </a:p>
-          <a:p>
-            <a:r>
-              <a:t>produce and to what standard. Objective → responsibilities → outcomes is the chain.</a:t>
-            </a:r>
-          </a:p>
-          <a:p>
-            <a:r>
-              <a:t>• Third bullet: shared, explicit objectives are exactly what let four separate component-writers pull</a:t>
-            </a:r>
-          </a:p>
-          <a:p>
-            <a:r>
-              <a:t>in ONE direction — without them you get four disconnected efforts.</a:t>
-            </a:r>
-          </a:p>
-          <a:p>
-            <a:r>
-              <a:t>Misconception to pre-empt: "the objective is obvious, we can skip stating it." No — unstated</a:t>
-            </a:r>
-          </a:p>
-          <a:p>
-            <a:r>
-              <a:t>objectives drift; making it explicit and shared is the assessable act, not a formality.</a:t>
-            </a:r>
-          </a:p>
-          <a:p>
-            <a:r>
-              <a:t>Question to pose: "What's the common objective of this build in one sentence — and could every member</a:t>
-            </a:r>
-          </a:p>
-          <a:p>
-            <a:r>
-              <a:t>say it the same way?" (tests whether it's genuinely shared).</a:t>
-            </a:r>
-          </a:p>
-          <a:p>
-            <a:r>
-              <a:t>UoC/AT2 tie: BSBXTW401 PC 1.1 (identify common objectives, responsibilities, required outcomes) →</a:t>
-            </a:r>
-          </a:p>
-          <a:p>
-            <a:r>
-              <a:t>evidenced in the AT2 team plan.</a:t>
+              <a:t>Workbook task 1. Unstated objectives drift — making it explicit and shared is the assessable act.</a:t>
+            </a:r>
+          </a:p>
+          <a:p>
+            <a:r>
+              <a:t>Test: could every member say the objective the same way?</a:t>
             </a:r>
           </a:p>
         </p:txBody>
@@ -948,72 +744,12 @@
           <a:lstStyle/>
           <a:p>
             <a:r>
-              <a:t>The how-to for setting expectations — a PERFORMANCE PLAN per member. Teach it as a measurable</a:t>
-            </a:r>
-          </a:p>
-          <a:p>
-            <a:r>
-              <a:t>instrument, not a pep talk.</a:t>
-            </a:r>
-          </a:p>
-          <a:p>
-            <a:r>
-              <a:t>• First bullet: a performance plan sets each member's expected outcomes, goals and behaviours for</a:t>
-            </a:r>
-          </a:p>
-          <a:p>
-            <a:r>
-              <a:t>THEIR component. One plan per person, tied to their part of the build.</a:t>
-            </a:r>
-          </a:p>
-          <a:p>
-            <a:r>
-              <a:t>• Second bullet: align each plan to the team objective AND to relevant policies — and make it</a:t>
-            </a:r>
-          </a:p>
-          <a:p>
-            <a:r>
-              <a:t>MEASURABLE. A plan is not a wish-list.</a:t>
-            </a:r>
-          </a:p>
-          <a:p>
-            <a:r>
-              <a:t>• Third bullet: read the worked example aloud — note it names an outcome, a standard, a deadline and a</a:t>
-            </a:r>
-          </a:p>
-          <a:p>
-            <a:r>
-              <a:t>collaboration behaviour. That's what "measurable" looks like.</a:t>
-            </a:r>
-          </a:p>
-          <a:p>
-            <a:r>
-              <a:t>Misconception to pre-empt: "a performance plan is vague encouragement." No — if you can't measure</a:t>
-            </a:r>
-          </a:p>
-          <a:p>
-            <a:r>
-              <a:t>whether it was met, it isn't a performance plan; the specificity is what's marked.</a:t>
-            </a:r>
-          </a:p>
-          <a:p>
-            <a:r>
-              <a:t>Question to pose: "Take the database owner — what would a good performance plan say their outcome,</a:t>
-            </a:r>
-          </a:p>
-          <a:p>
-            <a:r>
-              <a:t>standard and deadline are?" (forces a measurable draft).</a:t>
-            </a:r>
-          </a:p>
-          <a:p>
-            <a:r>
-              <a:t>UoC/AT2 tie: BSBXTW401 PC 1.2 (performance plans establishing expected outcomes/goals/behaviours in</a:t>
-            </a:r>
-          </a:p>
-          <a:p>
-            <a:r>
-              <a:t>line with the team objective and relevant policies) → the AT2 team plan.</a:t>
+              <a:t>Workbook task 2. If you can't measure whether it was met, it isn't a performance plan.</a:t>
+            </a:r>
+          </a:p>
+          <a:p>
+            <a:r>
+              <a:t>Draft one live for the database owner — outcome, standard, deadline, behaviour.</a:t>
             </a:r>
           </a:p>
         </p:txBody>
@@ -1083,72 +819,12 @@
           <a:lstStyle/>
           <a:p>
             <a:r>
-              <a:t>Section 1's third move — accountability, and crucially the two things it must be GROUNDED in. This is</a:t>
-            </a:r>
-          </a:p>
-          <a:p>
-            <a:r>
-              <a:t>where KE 1 and KE 2 land.</a:t>
-            </a:r>
-          </a:p>
-          <a:p>
-            <a:r>
-              <a:t>• First bullet: choose concrete accountability strategies — clear ownership per component, review</a:t>
-            </a:r>
-          </a:p>
-          <a:p>
-            <a:r>
-              <a:t>checkpoints, a shared definition of done. Name mechanisms, not slogans.</a:t>
-            </a:r>
-          </a:p>
-          <a:p>
-            <a:r>
-              <a:t>• Second bullet: ground them in ORGANISATIONAL requirements — workplace policies, codes of conduct,</a:t>
-            </a:r>
-          </a:p>
-          <a:p>
-            <a:r>
-              <a:t>and YAT's reputation and culture (KE 1). Accountability isn't invented; it sits on the org's rules.</a:t>
-            </a:r>
-          </a:p>
-          <a:p>
-            <a:r>
-              <a:t>• Third bullet: respect the LEGISLATIVE requirements relevant to the workplace — WHS, privacy,</a:t>
-            </a:r>
-          </a:p>
-          <a:p>
-            <a:r>
-              <a:t>anti-discrimination (KE 2). Accountability operates INSIDE those rules, never outside them.</a:t>
-            </a:r>
-          </a:p>
-          <a:p>
-            <a:r>
-              <a:t>Misconception to pre-empt: "accountability = blame when it goes wrong." No — it's the up-front</a:t>
-            </a:r>
-          </a:p>
-          <a:p>
-            <a:r>
-              <a:t>structure of ownership and checkpoints so work is owned and visible; it's preventive, not punitive.</a:t>
-            </a:r>
-          </a:p>
-          <a:p>
-            <a:r>
-              <a:t>Question to pose: "Name one organisational policy and one law that would shape how you hold this team</a:t>
-            </a:r>
-          </a:p>
-          <a:p>
-            <a:r>
-              <a:t>accountable" (draws out KE 1 vs KE 2 — they're different sources).</a:t>
-            </a:r>
-          </a:p>
-          <a:p>
-            <a:r>
-              <a:t>UoC/AT2 tie: BSBXTW401 PC 1.3 + KE 1 + KE 2 → the accountability strategies in the AT2 team plan,</a:t>
-            </a:r>
-          </a:p>
-          <a:p>
-            <a:r>
-              <a:t>grounded in organisational + legislative requirements.</a:t>
+              <a:t>Workbook task 3. Mechanisms, not slogans — and the grounding in policy and law is examinable.</a:t>
+            </a:r>
+          </a:p>
+          <a:p>
+            <a:r>
+              <a:t>Question to pose: one policy and one law that shape how this team holds the line.</a:t>
             </a:r>
           </a:p>
         </p:txBody>
@@ -1218,87 +894,12 @@
           <a:lstStyle/>
           <a:p>
             <a:r>
-              <a:t>Section 2 — contingency planning. Teach it as naming the failure modes BEFORE they happen, not</a:t>
-            </a:r>
-          </a:p>
-          <a:p>
-            <a:r>
-              <a:t>improvising under pressure.</a:t>
-            </a:r>
-          </a:p>
-          <a:p>
-            <a:r>
-              <a:t>• First bullet: plan for contingencies that could impact the team ahead of time — the point is you</a:t>
-            </a:r>
-          </a:p>
-          <a:p>
-            <a:r>
-              <a:t>decide the response while calm, not mid-crisis.</a:t>
-            </a:r>
-          </a:p>
-          <a:p>
-            <a:r>
-              <a:t>• Second bullet: name the TYPICAL workplace ones (KE 9) — unplanned leave or absence of a component</a:t>
-            </a:r>
-          </a:p>
-          <a:p>
-            <a:r>
-              <a:t>owner; re-allocation of work when load shifts; succession planning for important roles. These three</a:t>
-            </a:r>
-          </a:p>
-          <a:p>
-            <a:r>
-              <a:t>are the examinable list.</a:t>
-            </a:r>
-          </a:p>
-          <a:p>
-            <a:r>
-              <a:t>• Third bullet: make it concrete for this build — if the database-component owner is absent, who picks</a:t>
-            </a:r>
-          </a:p>
-          <a:p>
-            <a:r>
-              <a:t>it up, and how is the handover documented?</a:t>
-            </a:r>
-          </a:p>
-          <a:p>
-            <a:r>
-              <a:t>• Fourth bullet (the definition): a contingency is a NAMED TRIGGER plus a PRE-AGREED RESPONSE — write</a:t>
-            </a:r>
-          </a:p>
-          <a:p>
-            <a:r>
-              <a:t>it into the team plan.</a:t>
-            </a:r>
-          </a:p>
-          <a:p>
-            <a:r>
-              <a:t>Misconception to pre-empt: "contingency planning is just listing risks." No — a risk without a</a:t>
-            </a:r>
-          </a:p>
-          <a:p>
-            <a:r>
-              <a:t>pre-agreed trigger-and-response isn't a contingency; the response is the deliverable.</a:t>
-            </a:r>
-          </a:p>
-          <a:p>
-            <a:r>
-              <a:t>Question to pose: "Your compute-component owner goes on unplanned leave the day before the milestone —</a:t>
-            </a:r>
-          </a:p>
-          <a:p>
-            <a:r>
-              <a:t>what's your pre-agreed response?" (forces a trigger→response pair).</a:t>
-            </a:r>
-          </a:p>
-          <a:p>
-            <a:r>
-              <a:t>UoC/AT2 tie: BSBXTW401 PC 1.4 + KE 9 (plan for the typical workplace contingencies) → the</a:t>
-            </a:r>
-          </a:p>
-          <a:p>
-            <a:r>
-              <a:t>contingencies section of the AT2 team plan.</a:t>
+              <a:t>Activity = practice workbook tasks 1–3, done as a team, recorded individually.</a:t>
+            </a:r>
+          </a:p>
+          <a:p>
+            <a:r>
+              <a:t>Watch for pep-talk performance plans and slogan accountability — push mechanisms and measures.</a:t>
             </a:r>
           </a:p>
         </p:txBody>
@@ -1368,67 +969,12 @@
           <a:lstStyle/>
           <a:p>
             <a:r>
-              <a:t>Open Section 3 — coordination begins with COMMUNICATING the goal before any work is handed out.</a:t>
-            </a:r>
-          </a:p>
-          <a:p>
-            <a:r>
-              <a:t>• First bullet: communicate the common objectives and each member's responsibilities so everyone</a:t>
-            </a:r>
-          </a:p>
-          <a:p>
-            <a:r>
-              <a:t>shares the same picture of "done".</a:t>
-            </a:r>
-          </a:p>
-          <a:p>
-            <a:r>
-              <a:t>• Second bullet: CONFIRM understanding — run a kick-off where the team restates the goal and how the</a:t>
-            </a:r>
-          </a:p>
-          <a:p>
-            <a:r>
-              <a:t>four components integrate. Communication isn't done until it's been played back.</a:t>
-            </a:r>
-          </a:p>
-          <a:p>
-            <a:r>
-              <a:t>• Third bullet: this up-front clarity is precisely what prevents four components that don't fit</a:t>
-            </a:r>
-          </a:p>
-          <a:p>
-            <a:r>
-              <a:t>together — the integration failure is a communication failure.</a:t>
-            </a:r>
-          </a:p>
-          <a:p>
-            <a:r>
-              <a:t>Misconception to pre-empt: "I emailed the plan, so I've communicated it." No — communication is</a:t>
-            </a:r>
-          </a:p>
-          <a:p>
-            <a:r>
-              <a:t>confirmed shared understanding, not a sent message; the kick-off play-back is the evidence.</a:t>
-            </a:r>
-          </a:p>
-          <a:p>
-            <a:r>
-              <a:t>Question to pose: "How would you check the team actually shares the same picture of 'done' before they</a:t>
-            </a:r>
-          </a:p>
-          <a:p>
-            <a:r>
-              <a:t>start writing?" (draws out confirmation techniques).</a:t>
-            </a:r>
-          </a:p>
-          <a:p>
-            <a:r>
-              <a:t>UoC/AT2 tie: BSBXTW401 PC 2.1 (communicate common objectives and responsibilities) → the facilitated</a:t>
-            </a:r>
-          </a:p>
-          <a:p>
-            <a:r>
-              <a:t>set-up / kick-off evidenced in AT2.</a:t>
+              <a:t>Workbook task 4. A risk without a pre-agreed response isn't a contingency; the response is the deliverable.</a:t>
+            </a:r>
+          </a:p>
+          <a:p>
+            <a:r>
+              <a:t>The three named classics are the examinable list.</a:t>
             </a:r>
           </a:p>
         </p:txBody>
@@ -1498,87 +1044,12 @@
           <a:lstStyle/>
           <a:p>
             <a:r>
-              <a:t>The core allocation move — hand out the four components. Use the component-allocation diagram to show</a:t>
-            </a:r>
-          </a:p>
-          <a:p>
-            <a:r>
-              <a:t>four members mapping to four components that integrate into one design.</a:t>
-            </a:r>
-          </a:p>
-          <a:p>
-            <a:r>
-              <a:t>• First bullet: allocate the four IaC components — NETWORK, COMPUTE, DATABASE, STORAGE — one per</a:t>
-            </a:r>
-          </a:p>
-          <a:p>
-            <a:r>
-              <a:t>member, by expertise OR development potential (PC 2.2). Note "development potential" — you can</a:t>
-            </a:r>
-          </a:p>
-          <a:p>
-            <a:r>
-              <a:t>allocate to stretch someone, not only to their strength.</a:t>
-            </a:r>
-          </a:p>
-          <a:p>
-            <a:r>
-              <a:t>• Second bullet: give APPROPRIATE INSTRUCTION with each allocation — scope of the component, the</a:t>
-            </a:r>
-          </a:p>
-          <a:p>
-            <a:r>
-              <a:t>interfaces it must expose, and any required contingencies (PE 1). Allocation without instruction</a:t>
-            </a:r>
-          </a:p>
-          <a:p>
-            <a:r>
-              <a:t>isn't allocation.</a:t>
-            </a:r>
-          </a:p>
-          <a:p>
-            <a:r>
-              <a:t>• Third bullet (the seam point): the four integrate into ONE design — so allocate the SEAMS too</a:t>
-            </a:r>
-          </a:p>
-          <a:p>
-            <a:r>
-              <a:t>(shared parameters, dependencies), not just the boxes. That's what the diagram shows.</a:t>
-            </a:r>
-          </a:p>
-          <a:p>
-            <a:r>
-              <a:t>Misconception to pre-empt: "allocation = give each person a box and walk away." No — the assessable</a:t>
-            </a:r>
-          </a:p>
-          <a:p>
-            <a:r>
-              <a:t>part is the instruction and the seams; unmanaged interfaces are where the build breaks.</a:t>
-            </a:r>
-          </a:p>
-          <a:p>
-            <a:r>
-              <a:t>Question to pose: "You give the network component to your least experienced member for development —</a:t>
-            </a:r>
-          </a:p>
-          <a:p>
-            <a:r>
-              <a:t>what extra instruction and contingency does that allocation need?" (ties development potential to</a:t>
-            </a:r>
-          </a:p>
-          <a:p>
-            <a:r>
-              <a:t>instruction).</a:t>
-            </a:r>
-          </a:p>
-          <a:p>
-            <a:r>
-              <a:t>UoC/AT2 tie: BSBXTW401 PC 2.2 + PE 1 (allocate by expertise/development potential, with instruction</a:t>
-            </a:r>
-          </a:p>
-          <a:p>
-            <a:r>
-              <a:t>and required contingencies) → the task-allocation records in AT2.</a:t>
+              <a:t>Activity = practice workbook task 4.</a:t>
+            </a:r>
+          </a:p>
+          <a:p>
+            <a:r>
+              <a:t>Every row is trigger plus response — challenge any that are just risks listed.</a:t>
             </a:r>
           </a:p>
         </p:txBody>
@@ -1648,102 +1119,12 @@
           <a:lstStyle/>
           <a:p>
             <a:r>
-              <a:t>Facilitation — the Section 3 practice; students produce the WHOLE team plan for the PRACTICE</a:t>
-            </a:r>
-          </a:p>
-          <a:p>
-            <a:r>
-              <a:t>engagement, the same artefact they'll produce for the assessed Ledgerline team.</a:t>
-            </a:r>
-          </a:p>
-          <a:p>
-            <a:r>
-              <a:t>Tell students, in these words: "For the practice engagement, draft the team plan — common objective,</a:t>
-            </a:r>
-          </a:p>
-          <a:p>
-            <a:r>
-              <a:t>per-member performance plans, accountability strategies and contingencies — then allocate the four</a:t>
-            </a:r>
-          </a:p>
-          <a:p>
-            <a:r>
-              <a:t>components to four members with clear instruction and any contingencies."</a:t>
-            </a:r>
-          </a:p>
-          <a:p>
-            <a:r>
-              <a:t>Steps (put on the board):</a:t>
-            </a:r>
-          </a:p>
-          <a:p>
-            <a:r>
-              <a:t>1. State the common objective and break it into responsibilities/outcomes.</a:t>
-            </a:r>
-          </a:p>
-          <a:p>
-            <a:r>
-              <a:t>2. Write a measurable performance plan per member.</a:t>
-            </a:r>
-          </a:p>
-          <a:p>
-            <a:r>
-              <a:t>3. Choose accountability strategies (grounded in policy + law) and name the contingencies.</a:t>
-            </a:r>
-          </a:p>
-          <a:p>
-            <a:r>
-              <a:t>4. Allocate network / compute / database / storage — one per member — with instruction AND the seams</a:t>
-            </a:r>
-          </a:p>
-          <a:p>
-            <a:r>
-              <a:t>(shared parameters, dependencies).</a:t>
-            </a:r>
-          </a:p>
-          <a:p>
-            <a:r>
-              <a:t>Must produce: a team plan (objective, four performance plans, accountability, contingencies) plus an</a:t>
-            </a:r>
-          </a:p>
-          <a:p>
-            <a:r>
-              <a:t>allocation of the four components with instruction — the practice run of the assessed artefact.</a:t>
-            </a:r>
-          </a:p>
-          <a:p>
-            <a:r>
-              <a:t>Timing: ~30 min. Where they get stuck: they allocate the four boxes but forget the SEAMS and the</a:t>
-            </a:r>
-          </a:p>
-          <a:p>
-            <a:r>
-              <a:t>INSTRUCTION — circulate and push "what does the network owner need to expose to the compute owner?";</a:t>
-            </a:r>
-          </a:p>
-          <a:p>
-            <a:r>
-              <a:t>and performance plans come out as pep talk, not measurable.</a:t>
-            </a:r>
-          </a:p>
-          <a:p>
-            <a:r>
-              <a:t>Share-back prompt: take one team's allocation and ask the room where two components must agree an</a:t>
-            </a:r>
-          </a:p>
-          <a:p>
-            <a:r>
-              <a:t>interface — surface a seam.</a:t>
-            </a:r>
-          </a:p>
-          <a:p>
-            <a:r>
-              <a:t>No-leakage note: this is the PRACTICE engagement — AT2 assesses the SAME leadership on the Ledgerline</a:t>
-            </a:r>
-          </a:p>
-          <a:p>
-            <a:r>
-              <a:t>team (comparable, not identical); keep them on the practice vehicle here.</a:t>
+              <a:t>Workbook task 5. "Development potential" matters — you can allocate to stretch someone, with the extra instruction that implies.</a:t>
+            </a:r>
+          </a:p>
+          <a:p>
+            <a:r>
+              <a:t>The unmanaged interface is where the build breaks; the diagram shows the seams.</a:t>
             </a:r>
           </a:p>
         </p:txBody>
@@ -1813,67 +1194,12 @@
           <a:lstStyle/>
           <a:p>
             <a:r>
-              <a:t>Open Section 4 — facilitation. Teach the techniques that keep a divided team behaving as one.</a:t>
-            </a:r>
-          </a:p>
-          <a:p>
-            <a:r>
-              <a:t>• First bullet: facilitate OPEN and RESPECTFUL communication and collaboration between members</a:t>
-            </a:r>
-          </a:p>
-          <a:p>
-            <a:r>
-              <a:t>(PC 2.3) — the leader's job is to create the conditions, not to do all the talking.</a:t>
-            </a:r>
-          </a:p>
-          <a:p>
-            <a:r>
-              <a:t>• Second bullet: name facilitation techniques that build cohesion and effectiveness (KE 3) —</a:t>
-            </a:r>
-          </a:p>
-          <a:p>
-            <a:r>
-              <a:t>stand-ups, shared review, ground rules. These are concrete, nameable routines.</a:t>
-            </a:r>
-          </a:p>
-          <a:p>
-            <a:r>
-              <a:t>• Third bullet: match the METHOD and STYLE of communication to the message and the person (KE 6) —</a:t>
-            </a:r>
-          </a:p>
-          <a:p>
-            <a:r>
-              <a:t>synchronous for decisions, written for the record. Different messages need different channels.</a:t>
-            </a:r>
-          </a:p>
-          <a:p>
-            <a:r>
-              <a:t>Misconception to pre-empt: "good communication = more meetings." No — it's matching the channel to the</a:t>
-            </a:r>
-          </a:p>
-          <a:p>
-            <a:r>
-              <a:t>message; a decision needs a conversation, a record needs writing. The wrong channel is the waste.</a:t>
-            </a:r>
-          </a:p>
-          <a:p>
-            <a:r>
-              <a:t>Question to pose: "You need the team to agree an integration boundary AND you need a durable record of</a:t>
-            </a:r>
-          </a:p>
-          <a:p>
-            <a:r>
-              <a:t>it — what method(s) do you use, and why both?" (draws out KE 6 method-to-message).</a:t>
-            </a:r>
-          </a:p>
-          <a:p>
-            <a:r>
-              <a:t>UoC/AT2 tie: BSBXTW401 PC 2.3 + KE 3 + KE 6 (facilitate open/respectful collaboration; techniques;</a:t>
-            </a:r>
-          </a:p>
-          <a:p>
-            <a:r>
-              <a:t>methods/styles) → the facilitated collaboration evidenced in AT2.</a:t>
+              <a:t>Workbook task 6 — the outside-team agreement is its own task.</a:t>
+            </a:r>
+          </a:p>
+          <a:p>
+            <a:r>
+              <a:t>Communication isn't done until it's played back; a decision needs a conversation, a record needs writing.</a:t>
             </a:r>
           </a:p>
         </p:txBody>
@@ -4976,7 +4302,7 @@
                 </a:solidFill>
                 <a:latin typeface="Roboto"/>
               </a:rPr>
-              <a:t>Leading and planning the team build</a:t>
+              <a:t>Establishing the build team</a:t>
             </a:r>
           </a:p>
           <a:p>
@@ -4992,7 +4318,7 @@
                 </a:solidFill>
                 <a:latin typeface="Roboto Light"/>
               </a:rPr>
-              <a:t/>
+              <a:t>Agree the objective, set expectations, plan for trouble, allocate the work</a:t>
             </a:r>
           </a:p>
         </p:txBody>
@@ -5095,7 +4421,7 @@
                 </a:solidFill>
                 <a:latin typeface="Roboto"/>
               </a:rPr>
-              <a:t>Communicate the objectives &amp; responsibilities</a:t>
+              <a:t>The typical contingencies</a:t>
             </a:r>
           </a:p>
         </p:txBody>
@@ -5115,7 +4441,7 @@
             <a:avLst/>
           </a:prstGeom>
           <a:solidFill>
-            <a:srgbClr val="205F61"/>
+            <a:srgbClr val="27B5CE"/>
           </a:solidFill>
           <a:ln>
             <a:noFill/>
@@ -5193,7 +4519,7 @@
                 </a:solidFill>
                 <a:latin typeface="Roboto"/>
               </a:rPr>
-              <a:t>Communicate the common objectives and each member's responsibilities so everyone shares the same picture of "done".</a:t>
+              <a:t>The workplace classics: unplanned absence of a component owner, re-allocation when load shifts, succession for important roles.</a:t>
             </a:r>
           </a:p>
           <a:p>
@@ -5224,7 +4550,7 @@
                 </a:solidFill>
                 <a:latin typeface="Roboto"/>
               </a:rPr>
-              <a:t>Confirm understanding — a kick-off where the team restates the goal and how the four components integrate.</a:t>
+              <a:t>A contingency is a named trigger plus a pre-agreed response — written into the team plan, decided before it's needed.</a:t>
             </a:r>
           </a:p>
           <a:p>
@@ -5255,7 +4581,7 @@
                 </a:solidFill>
                 <a:latin typeface="Roboto"/>
               </a:rPr>
-              <a:t>Clear communication up front is what prevents four components that don't fit together.</a:t>
+              <a:t>For this build: the database owner is out the day before the milestone — who picks it up, and how is the handover recorded?</a:t>
             </a:r>
           </a:p>
         </p:txBody>
@@ -5275,7 +4601,7 @@
             <a:avLst/>
           </a:prstGeom>
           <a:solidFill>
-            <a:srgbClr val="205F61"/>
+            <a:srgbClr val="27B5CE"/>
           </a:solidFill>
           <a:ln>
             <a:noFill/>
@@ -5377,7 +4703,7 @@
                 </a:solidFill>
                 <a:latin typeface="Roboto"/>
               </a:rPr>
-              <a:t>6</a:t>
+              <a:t>7</a:t>
             </a:r>
           </a:p>
         </p:txBody>
@@ -5410,54 +4736,20 @@
       <p:grpSpPr/>
       <p:sp>
         <p:nvSpPr>
-          <p:cNvPr id="2" name="TextBox 1"/>
-          <p:cNvSpPr txBox="1"/>
-          <p:nvPr/>
-        </p:nvSpPr>
-        <p:spPr>
-          <a:xfrm>
-            <a:off x="640080" y="457200"/>
-            <a:ext cx="10881360" cy="960120"/>
-          </a:xfrm>
-          <a:prstGeom prst="rect">
-            <a:avLst/>
-          </a:prstGeom>
-          <a:noFill/>
-        </p:spPr>
-        <p:txBody>
-          <a:bodyPr wrap="square" anchor="t" lIns="0" rIns="0" tIns="0" bIns="0">
-            <a:spAutoFit/>
-          </a:bodyPr>
-          <a:lstStyle/>
-          <a:p>
-            <a:r>
-              <a:rPr sz="2800" b="1" i="0">
-                <a:solidFill>
-                  <a:srgbClr val="2A2929"/>
-                </a:solidFill>
-                <a:latin typeface="Roboto"/>
-              </a:rPr>
-              <a:t>Allocate the four components</a:t>
-            </a:r>
-          </a:p>
-        </p:txBody>
-      </p:sp>
-      <p:sp>
-        <p:nvSpPr>
-          <p:cNvPr id="3" name="Rectangle 2"/>
+          <p:cNvPr id="2" name="Rectangle 1"/>
           <p:cNvSpPr/>
           <p:nvPr/>
         </p:nvSpPr>
         <p:spPr>
           <a:xfrm>
-            <a:off x="658368" y="1371600"/>
-            <a:ext cx="1463040" cy="50800"/>
+            <a:off x="0" y="0"/>
+            <a:ext cx="12191695" cy="1234440"/>
           </a:xfrm>
           <a:prstGeom prst="rect">
             <a:avLst/>
           </a:prstGeom>
           <a:solidFill>
-            <a:srgbClr val="205F61"/>
+            <a:srgbClr val="27B5CE"/>
           </a:solidFill>
           <a:ln>
             <a:noFill/>
@@ -5488,14 +4780,101 @@
       </p:sp>
       <p:sp>
         <p:nvSpPr>
+          <p:cNvPr id="3" name="Rounded Rectangle 2"/>
+          <p:cNvSpPr/>
+          <p:nvPr/>
+        </p:nvSpPr>
+        <p:spPr>
+          <a:xfrm>
+            <a:off x="640080" y="384048"/>
+            <a:ext cx="1691640" cy="457200"/>
+          </a:xfrm>
+          <a:prstGeom prst="roundRect">
+            <a:avLst/>
+          </a:prstGeom>
+          <a:solidFill>
+            <a:srgbClr val="2A2929"/>
+          </a:solidFill>
+          <a:ln>
+            <a:noFill/>
+          </a:ln>
+          <a:effectLst/>
+        </p:spPr>
+        <p:style>
+          <a:lnRef idx="1">
+            <a:schemeClr val="accent1"/>
+          </a:lnRef>
+          <a:fillRef idx="3">
+            <a:schemeClr val="accent1"/>
+          </a:fillRef>
+          <a:effectRef idx="2">
+            <a:schemeClr val="accent1"/>
+          </a:effectRef>
+          <a:fontRef idx="minor">
+            <a:schemeClr val="lt1"/>
+          </a:fontRef>
+        </p:style>
+        <p:txBody>
+          <a:bodyPr rtlCol="0" anchor="ctr"/>
+          <a:lstStyle/>
+          <a:p>
+            <a:pPr algn="ctr"/>
+            <a:r>
+              <a:rPr sz="1400" b="1" i="0">
+                <a:solidFill>
+                  <a:srgbClr val="FBB900"/>
+                </a:solidFill>
+                <a:latin typeface="Roboto"/>
+              </a:rPr>
+              <a:t>ACTIVITY</a:t>
+            </a:r>
+          </a:p>
+        </p:txBody>
+      </p:sp>
+      <p:sp>
+        <p:nvSpPr>
           <p:cNvPr id="4" name="TextBox 3"/>
           <p:cNvSpPr txBox="1"/>
           <p:nvPr/>
         </p:nvSpPr>
         <p:spPr>
           <a:xfrm>
-            <a:off x="658368" y="1737360"/>
-            <a:ext cx="5486400" cy="4297680"/>
+            <a:off x="2560320" y="310896"/>
+            <a:ext cx="8961120" cy="685800"/>
+          </a:xfrm>
+          <a:prstGeom prst="rect">
+            <a:avLst/>
+          </a:prstGeom>
+          <a:noFill/>
+        </p:spPr>
+        <p:txBody>
+          <a:bodyPr wrap="square" anchor="ctr" lIns="0" rIns="0" tIns="0" bIns="0">
+            <a:spAutoFit/>
+          </a:bodyPr>
+          <a:lstStyle/>
+          <a:p>
+            <a:r>
+              <a:rPr sz="2600" b="1" i="0">
+                <a:solidFill>
+                  <a:srgbClr val="FFFFFF"/>
+                </a:solidFill>
+                <a:latin typeface="Roboto"/>
+              </a:rPr>
+              <a:t>Plan the contingencies</a:t>
+            </a:r>
+          </a:p>
+        </p:txBody>
+      </p:sp>
+      <p:sp>
+        <p:nvSpPr>
+          <p:cNvPr id="5" name="TextBox 4"/>
+          <p:cNvSpPr txBox="1"/>
+          <p:nvPr/>
+        </p:nvSpPr>
+        <p:spPr>
+          <a:xfrm>
+            <a:off x="658368" y="1554480"/>
+            <a:ext cx="10881360" cy="4297680"/>
           </a:xfrm>
           <a:prstGeom prst="rect">
             <a:avLst/>
@@ -5535,7 +4914,7 @@
                 </a:solidFill>
                 <a:latin typeface="Roboto"/>
               </a:rPr>
-              <a:t>Allocate the four IaC components — network, compute, database, storage — one per member, by expertise or development potential (PC 2.2).</a:t>
+              <a:t>Workbook — task 4.</a:t>
             </a:r>
           </a:p>
           <a:p>
@@ -5566,69 +4945,94 @@
                 </a:solidFill>
                 <a:latin typeface="Roboto"/>
               </a:rPr>
-              <a:t>Give appropriate instruction with each allocation: scope of the component, the interfaces it must expose, and any required contingencies (PE 1).</a:t>
-            </a:r>
-          </a:p>
-          <a:p>
-            <a:pPr marL="0" indent="0">
-              <a:lnSpc>
-                <a:spcPct val="105000"/>
-              </a:lnSpc>
-              <a:spcBef>
-                <a:spcPts val="0"/>
-              </a:spcBef>
-              <a:spcAft>
-                <a:spcPts val="1000"/>
-              </a:spcAft>
-            </a:pPr>
-            <a:r>
-              <a:rPr sz="1700" b="1" i="0">
-                <a:solidFill>
-                  <a:srgbClr val="EDAB0C"/>
-                </a:solidFill>
-                <a:latin typeface="Roboto"/>
-              </a:rPr>
-              <a:t>■  </a:t>
-            </a:r>
-            <a:r>
-              <a:rPr sz="1700" b="0" i="0">
+              <a:t>Write the team's contingencies: the triggers that could hurt the build, and the response agreed for each.</a:t>
+            </a:r>
+          </a:p>
+        </p:txBody>
+      </p:sp>
+      <p:sp>
+        <p:nvSpPr>
+          <p:cNvPr id="6" name="Rounded Rectangle 5"/>
+          <p:cNvSpPr/>
+          <p:nvPr/>
+        </p:nvSpPr>
+        <p:spPr>
+          <a:xfrm>
+            <a:off x="640080" y="5897880"/>
+            <a:ext cx="4023360" cy="457200"/>
+          </a:xfrm>
+          <a:prstGeom prst="roundRect">
+            <a:avLst/>
+          </a:prstGeom>
+          <a:solidFill>
+            <a:srgbClr val="F9F9F9"/>
+          </a:solidFill>
+          <a:ln w="12700">
+            <a:solidFill>
+              <a:srgbClr val="CCCCCC"/>
+            </a:solidFill>
+          </a:ln>
+          <a:effectLst/>
+        </p:spPr>
+        <p:style>
+          <a:lnRef idx="1">
+            <a:schemeClr val="accent1"/>
+          </a:lnRef>
+          <a:fillRef idx="3">
+            <a:schemeClr val="accent1"/>
+          </a:fillRef>
+          <a:effectRef idx="2">
+            <a:schemeClr val="accent1"/>
+          </a:effectRef>
+          <a:fontRef idx="minor">
+            <a:schemeClr val="lt1"/>
+          </a:fontRef>
+        </p:style>
+        <p:txBody>
+          <a:bodyPr rtlCol="0" anchor="ctr"/>
+          <a:lstStyle/>
+          <a:p>
+            <a:pPr algn="ctr"/>
+          </a:p>
+        </p:txBody>
+      </p:sp>
+      <p:sp>
+        <p:nvSpPr>
+          <p:cNvPr id="7" name="TextBox 6"/>
+          <p:cNvSpPr txBox="1"/>
+          <p:nvPr/>
+        </p:nvSpPr>
+        <p:spPr>
+          <a:xfrm>
+            <a:off x="822960" y="5943600"/>
+            <a:ext cx="3657600" cy="365760"/>
+          </a:xfrm>
+          <a:prstGeom prst="rect">
+            <a:avLst/>
+          </a:prstGeom>
+          <a:noFill/>
+        </p:spPr>
+        <p:txBody>
+          <a:bodyPr wrap="square" anchor="ctr" lIns="0" rIns="0" tIns="0" bIns="0">
+            <a:spAutoFit/>
+          </a:bodyPr>
+          <a:lstStyle/>
+          <a:p>
+            <a:r>
+              <a:rPr sz="1500" b="1" i="0">
                 <a:solidFill>
                   <a:srgbClr val="2A2929"/>
                 </a:solidFill>
                 <a:latin typeface="Roboto"/>
               </a:rPr>
-              <a:t>The four allocations integrate into one design — allocate the seams (shared parameters, dependencies), not just the boxes.</a:t>
-            </a:r>
-          </a:p>
-        </p:txBody>
-      </p:sp>
-      <p:pic>
-        <p:nvPicPr>
-          <p:cNvPr id="5" name="Picture 4" descr="component-allocation.png"/>
-          <p:cNvPicPr>
-            <a:picLocks noChangeAspect="1"/>
-          </p:cNvPicPr>
-          <p:nvPr/>
-        </p:nvPicPr>
-        <p:blipFill>
-          <a:blip r:embed="rId2"/>
-          <a:stretch>
-            <a:fillRect/>
-          </a:stretch>
-        </p:blipFill>
-        <p:spPr>
-          <a:xfrm>
-            <a:off x="6400800" y="2811780"/>
-            <a:ext cx="5120640" cy="1965960"/>
-          </a:xfrm>
-          <a:prstGeom prst="rect">
-            <a:avLst/>
-          </a:prstGeom>
-        </p:spPr>
-      </p:pic>
-      <p:sp>
-        <p:nvSpPr>
-          <p:cNvPr id="6" name="Rectangle 5"/>
+              <a:t>⏱  ~20 min</a:t>
+            </a:r>
+          </a:p>
+        </p:txBody>
+      </p:sp>
+      <p:sp>
+        <p:nvSpPr>
+          <p:cNvPr id="8" name="Rectangle 7"/>
           <p:cNvSpPr/>
           <p:nvPr/>
         </p:nvSpPr>
@@ -5641,7 +5045,7 @@
             <a:avLst/>
           </a:prstGeom>
           <a:solidFill>
-            <a:srgbClr val="205F61"/>
+            <a:srgbClr val="27B5CE"/>
           </a:solidFill>
           <a:ln>
             <a:noFill/>
@@ -5672,7 +5076,7 @@
       </p:sp>
       <p:sp>
         <p:nvSpPr>
-          <p:cNvPr id="7" name="TextBox 6"/>
+          <p:cNvPr id="9" name="TextBox 8"/>
           <p:cNvSpPr txBox="1"/>
           <p:nvPr/>
         </p:nvSpPr>
@@ -5715,7 +5119,7 @@
       </p:sp>
       <p:sp>
         <p:nvSpPr>
-          <p:cNvPr id="8" name="TextBox 7"/>
+          <p:cNvPr id="10" name="TextBox 9"/>
           <p:cNvSpPr txBox="1"/>
           <p:nvPr/>
         </p:nvSpPr>
@@ -5743,7 +5147,7 @@
                 </a:solidFill>
                 <a:latin typeface="Roboto"/>
               </a:rPr>
-              <a:t>7</a:t>
+              <a:t>8</a:t>
             </a:r>
           </a:p>
         </p:txBody>
@@ -5762,7 +5166,7 @@
     <p:bg>
       <p:bgPr>
         <a:solidFill>
-          <a:srgbClr val="FFFFFF"/>
+          <a:srgbClr val="F9F9F9"/>
         </a:solidFill>
         <a:effectLst/>
       </p:bgPr>
@@ -5776,20 +5180,70 @@
       <p:grpSpPr/>
       <p:sp>
         <p:nvSpPr>
-          <p:cNvPr id="2" name="Rectangle 1"/>
+          <p:cNvPr id="2" name="TextBox 1"/>
+          <p:cNvSpPr txBox="1"/>
+          <p:nvPr/>
+        </p:nvSpPr>
+        <p:spPr>
+          <a:xfrm>
+            <a:off x="640080" y="548640"/>
+            <a:ext cx="10881360" cy="1097280"/>
+          </a:xfrm>
+          <a:prstGeom prst="rect">
+            <a:avLst/>
+          </a:prstGeom>
+          <a:noFill/>
+        </p:spPr>
+        <p:txBody>
+          <a:bodyPr wrap="square" anchor="t" lIns="0" rIns="0" tIns="0" bIns="0">
+            <a:spAutoFit/>
+          </a:bodyPr>
+          <a:lstStyle/>
+          <a:p>
+            <a:r>
+              <a:rPr sz="3200" b="1" i="0">
+                <a:solidFill>
+                  <a:srgbClr val="2A2929"/>
+                </a:solidFill>
+                <a:latin typeface="Roboto"/>
+              </a:rPr>
+              <a:t>Key takeaways</a:t>
+            </a:r>
+          </a:p>
+          <a:p>
+            <a:pPr>
+              <a:spcBef>
+                <a:spcPts val="200"/>
+              </a:spcBef>
+            </a:pPr>
+            <a:r>
+              <a:rPr sz="1800" b="1" i="0">
+                <a:solidFill>
+                  <a:srgbClr val="27B5CE"/>
+                </a:solidFill>
+                <a:latin typeface="Roboto"/>
+              </a:rPr>
+              <a:t>Section 2 · Contingencies</a:t>
+            </a:r>
+          </a:p>
+        </p:txBody>
+      </p:sp>
+      <p:sp>
+        <p:nvSpPr>
+          <p:cNvPr id="3" name="Rectangle 2"/>
           <p:cNvSpPr/>
           <p:nvPr/>
         </p:nvSpPr>
         <p:spPr>
           <a:xfrm>
-            <a:off x="0" y="0"/>
-            <a:ext cx="12191695" cy="1234440"/>
+            <a:off x="658368" y="1600200"/>
+            <a:ext cx="1463040" cy="50800"/>
           </a:xfrm>
           <a:prstGeom prst="rect">
             <a:avLst/>
           </a:prstGeom>
           <a:solidFill>
-            <a:srgbClr val="205F61"/>
+            <a:srgbClr val="27B5CE"/>
           </a:solidFill>
           <a:ln>
             <a:noFill/>
@@ -5820,223 +5274,20 @@
       </p:sp>
       <p:sp>
         <p:nvSpPr>
-          <p:cNvPr id="3" name="Rounded Rectangle 2"/>
+          <p:cNvPr id="4" name="Rectangle 3"/>
           <p:cNvSpPr/>
           <p:nvPr/>
         </p:nvSpPr>
         <p:spPr>
           <a:xfrm>
-            <a:off x="640080" y="384048"/>
-            <a:ext cx="1691640" cy="457200"/>
-          </a:xfrm>
-          <a:prstGeom prst="roundRect">
+            <a:off x="640080" y="1965960"/>
+            <a:ext cx="10927080" cy="841248"/>
+          </a:xfrm>
+          <a:prstGeom prst="rect">
             <a:avLst/>
           </a:prstGeom>
           <a:solidFill>
-            <a:srgbClr val="2A2929"/>
-          </a:solidFill>
-          <a:ln>
-            <a:noFill/>
-          </a:ln>
-          <a:effectLst/>
-        </p:spPr>
-        <p:style>
-          <a:lnRef idx="1">
-            <a:schemeClr val="accent1"/>
-          </a:lnRef>
-          <a:fillRef idx="3">
-            <a:schemeClr val="accent1"/>
-          </a:fillRef>
-          <a:effectRef idx="2">
-            <a:schemeClr val="accent1"/>
-          </a:effectRef>
-          <a:fontRef idx="minor">
-            <a:schemeClr val="lt1"/>
-          </a:fontRef>
-        </p:style>
-        <p:txBody>
-          <a:bodyPr rtlCol="0" anchor="ctr"/>
-          <a:lstStyle/>
-          <a:p>
-            <a:pPr algn="ctr"/>
-            <a:r>
-              <a:rPr sz="1400" b="1" i="0">
-                <a:solidFill>
-                  <a:srgbClr val="FBB900"/>
-                </a:solidFill>
-                <a:latin typeface="Roboto"/>
-              </a:rPr>
-              <a:t>ACTIVITY</a:t>
-            </a:r>
-          </a:p>
-        </p:txBody>
-      </p:sp>
-      <p:sp>
-        <p:nvSpPr>
-          <p:cNvPr id="4" name="TextBox 3"/>
-          <p:cNvSpPr txBox="1"/>
-          <p:nvPr/>
-        </p:nvSpPr>
-        <p:spPr>
-          <a:xfrm>
-            <a:off x="2560320" y="310896"/>
-            <a:ext cx="8961120" cy="685800"/>
-          </a:xfrm>
-          <a:prstGeom prst="rect">
-            <a:avLst/>
-          </a:prstGeom>
-          <a:noFill/>
-        </p:spPr>
-        <p:txBody>
-          <a:bodyPr wrap="square" anchor="ctr" lIns="0" rIns="0" tIns="0" bIns="0">
-            <a:spAutoFit/>
-          </a:bodyPr>
-          <a:lstStyle/>
-          <a:p>
-            <a:r>
-              <a:rPr sz="2600" b="1" i="0">
-                <a:solidFill>
-                  <a:srgbClr val="FFFFFF"/>
-                </a:solidFill>
-                <a:latin typeface="Roboto"/>
-              </a:rPr>
-              <a:t>Plan &amp; allocate the practice build team</a:t>
-            </a:r>
-          </a:p>
-        </p:txBody>
-      </p:sp>
-      <p:sp>
-        <p:nvSpPr>
-          <p:cNvPr id="5" name="TextBox 4"/>
-          <p:cNvSpPr txBox="1"/>
-          <p:nvPr/>
-        </p:nvSpPr>
-        <p:spPr>
-          <a:xfrm>
-            <a:off x="658368" y="1554480"/>
-            <a:ext cx="10881360" cy="4297680"/>
-          </a:xfrm>
-          <a:prstGeom prst="rect">
-            <a:avLst/>
-          </a:prstGeom>
-          <a:noFill/>
-        </p:spPr>
-        <p:txBody>
-          <a:bodyPr wrap="square" anchor="t" lIns="0" rIns="0" tIns="0" bIns="0">
-            <a:spAutoFit/>
-          </a:bodyPr>
-          <a:lstStyle/>
-          <a:p>
-            <a:pPr marL="0" indent="0">
-              <a:lnSpc>
-                <a:spcPct val="105000"/>
-              </a:lnSpc>
-              <a:spcBef>
-                <a:spcPts val="0"/>
-              </a:spcBef>
-              <a:spcAft>
-                <a:spcPts val="1000"/>
-              </a:spcAft>
-            </a:pPr>
-            <a:r>
-              <a:rPr sz="1700" b="1" i="0">
-                <a:solidFill>
-                  <a:srgbClr val="EDAB0C"/>
-                </a:solidFill>
-                <a:latin typeface="Roboto"/>
-              </a:rPr>
-              <a:t>■  </a:t>
-            </a:r>
-            <a:r>
-              <a:rPr sz="1700" b="0" i="0">
-                <a:solidFill>
-                  <a:srgbClr val="2A2929"/>
-                </a:solidFill>
-                <a:latin typeface="Roboto"/>
-              </a:rPr>
-              <a:t>For the practice engagement, draft the team plan: common objective, per-member performance plans, accountability strategies and contingencies.</a:t>
-            </a:r>
-          </a:p>
-          <a:p>
-            <a:pPr marL="0" indent="0">
-              <a:lnSpc>
-                <a:spcPct val="105000"/>
-              </a:lnSpc>
-              <a:spcBef>
-                <a:spcPts val="0"/>
-              </a:spcBef>
-              <a:spcAft>
-                <a:spcPts val="1000"/>
-              </a:spcAft>
-            </a:pPr>
-            <a:r>
-              <a:rPr sz="1700" b="1" i="0">
-                <a:solidFill>
-                  <a:srgbClr val="EDAB0C"/>
-                </a:solidFill>
-                <a:latin typeface="Roboto"/>
-              </a:rPr>
-              <a:t>■  </a:t>
-            </a:r>
-            <a:r>
-              <a:rPr sz="1700" b="0" i="0">
-                <a:solidFill>
-                  <a:srgbClr val="2A2929"/>
-                </a:solidFill>
-                <a:latin typeface="Roboto"/>
-              </a:rPr>
-              <a:t>Allocate the four components to four members with clear instruction and any required contingencies.</a:t>
-            </a:r>
-          </a:p>
-          <a:p>
-            <a:pPr marL="0" indent="0">
-              <a:lnSpc>
-                <a:spcPct val="105000"/>
-              </a:lnSpc>
-              <a:spcBef>
-                <a:spcPts val="0"/>
-              </a:spcBef>
-              <a:spcAft>
-                <a:spcPts val="1000"/>
-              </a:spcAft>
-            </a:pPr>
-            <a:r>
-              <a:rPr sz="1700" b="1" i="0">
-                <a:solidFill>
-                  <a:srgbClr val="EDAB0C"/>
-                </a:solidFill>
-                <a:latin typeface="Roboto"/>
-              </a:rPr>
-              <a:t>■  </a:t>
-            </a:r>
-            <a:r>
-              <a:rPr sz="1700" b="0" i="0">
-                <a:solidFill>
-                  <a:srgbClr val="2A2929"/>
-                </a:solidFill>
-                <a:latin typeface="Roboto"/>
-              </a:rPr>
-              <a:t>Produce the artefact you'll produce for the assessed Ledgerline team — this is the practice run.</a:t>
-            </a:r>
-          </a:p>
-        </p:txBody>
-      </p:sp>
-      <p:sp>
-        <p:nvSpPr>
-          <p:cNvPr id="6" name="Rounded Rectangle 5"/>
-          <p:cNvSpPr/>
-          <p:nvPr/>
-        </p:nvSpPr>
-        <p:spPr>
-          <a:xfrm>
-            <a:off x="640080" y="5897880"/>
-            <a:ext cx="4023360" cy="457200"/>
-          </a:xfrm>
-          <a:prstGeom prst="roundRect">
-            <a:avLst/>
-          </a:prstGeom>
-          <a:solidFill>
-            <a:srgbClr val="F9F9F9"/>
+            <a:srgbClr val="FFFFFF"/>
           </a:solidFill>
           <a:ln w="12700">
             <a:solidFill>
@@ -6069,54 +5320,20 @@
       </p:sp>
       <p:sp>
         <p:nvSpPr>
-          <p:cNvPr id="7" name="TextBox 6"/>
-          <p:cNvSpPr txBox="1"/>
-          <p:nvPr/>
-        </p:nvSpPr>
-        <p:spPr>
-          <a:xfrm>
-            <a:off x="822960" y="5943600"/>
-            <a:ext cx="3657600" cy="365760"/>
-          </a:xfrm>
-          <a:prstGeom prst="rect">
-            <a:avLst/>
-          </a:prstGeom>
-          <a:noFill/>
-        </p:spPr>
-        <p:txBody>
-          <a:bodyPr wrap="square" anchor="ctr" lIns="0" rIns="0" tIns="0" bIns="0">
-            <a:spAutoFit/>
-          </a:bodyPr>
-          <a:lstStyle/>
-          <a:p>
-            <a:r>
-              <a:rPr sz="1500" b="1" i="0">
-                <a:solidFill>
-                  <a:srgbClr val="2A2929"/>
-                </a:solidFill>
-                <a:latin typeface="Roboto"/>
-              </a:rPr>
-              <a:t>⏱  ~30 min</a:t>
-            </a:r>
-          </a:p>
-        </p:txBody>
-      </p:sp>
-      <p:sp>
-        <p:nvSpPr>
-          <p:cNvPr id="8" name="Rectangle 7"/>
+          <p:cNvPr id="5" name="Rectangle 4"/>
           <p:cNvSpPr/>
           <p:nvPr/>
         </p:nvSpPr>
         <p:spPr>
           <a:xfrm>
-            <a:off x="0" y="6565392"/>
-            <a:ext cx="12191695" cy="38100"/>
+            <a:off x="640080" y="1965960"/>
+            <a:ext cx="109728" cy="841248"/>
           </a:xfrm>
           <a:prstGeom prst="rect">
             <a:avLst/>
           </a:prstGeom>
           <a:solidFill>
-            <a:srgbClr val="205F61"/>
+            <a:srgbClr val="27B5CE"/>
           </a:solidFill>
           <a:ln>
             <a:noFill/>
@@ -6147,7 +5364,219 @@
       </p:sp>
       <p:sp>
         <p:nvSpPr>
+          <p:cNvPr id="6" name="TextBox 5"/>
+          <p:cNvSpPr txBox="1"/>
+          <p:nvPr/>
+        </p:nvSpPr>
+        <p:spPr>
+          <a:xfrm>
+            <a:off x="960120" y="1965960"/>
+            <a:ext cx="10424160" cy="841248"/>
+          </a:xfrm>
+          <a:prstGeom prst="rect">
+            <a:avLst/>
+          </a:prstGeom>
+          <a:noFill/>
+        </p:spPr>
+        <p:txBody>
+          <a:bodyPr wrap="square" anchor="ctr" lIns="0" rIns="0" tIns="0" bIns="0">
+            <a:spAutoFit/>
+          </a:bodyPr>
+          <a:lstStyle/>
+          <a:p>
+            <a:pPr>
+              <a:lnSpc>
+                <a:spcPct val="100000"/>
+              </a:lnSpc>
+            </a:pPr>
+            <a:r>
+              <a:rPr sz="1700" b="0" i="0">
+                <a:solidFill>
+                  <a:srgbClr val="2A2929"/>
+                </a:solidFill>
+                <a:latin typeface="Roboto"/>
+              </a:rPr>
+              <a:t>Absence, re-allocation, succession — planned before they happen.</a:t>
+            </a:r>
+          </a:p>
+        </p:txBody>
+      </p:sp>
+      <p:sp>
+        <p:nvSpPr>
+          <p:cNvPr id="7" name="Rectangle 6"/>
+          <p:cNvSpPr/>
+          <p:nvPr/>
+        </p:nvSpPr>
+        <p:spPr>
+          <a:xfrm>
+            <a:off x="640080" y="2916936"/>
+            <a:ext cx="10927080" cy="841248"/>
+          </a:xfrm>
+          <a:prstGeom prst="rect">
+            <a:avLst/>
+          </a:prstGeom>
+          <a:solidFill>
+            <a:srgbClr val="FFFFFF"/>
+          </a:solidFill>
+          <a:ln w="12700">
+            <a:solidFill>
+              <a:srgbClr val="CCCCCC"/>
+            </a:solidFill>
+          </a:ln>
+          <a:effectLst/>
+        </p:spPr>
+        <p:style>
+          <a:lnRef idx="1">
+            <a:schemeClr val="accent1"/>
+          </a:lnRef>
+          <a:fillRef idx="3">
+            <a:schemeClr val="accent1"/>
+          </a:fillRef>
+          <a:effectRef idx="2">
+            <a:schemeClr val="accent1"/>
+          </a:effectRef>
+          <a:fontRef idx="minor">
+            <a:schemeClr val="lt1"/>
+          </a:fontRef>
+        </p:style>
+        <p:txBody>
+          <a:bodyPr rtlCol="0" anchor="ctr"/>
+          <a:lstStyle/>
+          <a:p>
+            <a:pPr algn="ctr"/>
+          </a:p>
+        </p:txBody>
+      </p:sp>
+      <p:sp>
+        <p:nvSpPr>
+          <p:cNvPr id="8" name="Rectangle 7"/>
+          <p:cNvSpPr/>
+          <p:nvPr/>
+        </p:nvSpPr>
+        <p:spPr>
+          <a:xfrm>
+            <a:off x="640080" y="2916936"/>
+            <a:ext cx="109728" cy="841248"/>
+          </a:xfrm>
+          <a:prstGeom prst="rect">
+            <a:avLst/>
+          </a:prstGeom>
+          <a:solidFill>
+            <a:srgbClr val="27B5CE"/>
+          </a:solidFill>
+          <a:ln>
+            <a:noFill/>
+          </a:ln>
+          <a:effectLst/>
+        </p:spPr>
+        <p:style>
+          <a:lnRef idx="1">
+            <a:schemeClr val="accent1"/>
+          </a:lnRef>
+          <a:fillRef idx="3">
+            <a:schemeClr val="accent1"/>
+          </a:fillRef>
+          <a:effectRef idx="2">
+            <a:schemeClr val="accent1"/>
+          </a:effectRef>
+          <a:fontRef idx="minor">
+            <a:schemeClr val="lt1"/>
+          </a:fontRef>
+        </p:style>
+        <p:txBody>
+          <a:bodyPr rtlCol="0" anchor="ctr"/>
+          <a:lstStyle/>
+          <a:p>
+            <a:pPr algn="ctr"/>
+          </a:p>
+        </p:txBody>
+      </p:sp>
+      <p:sp>
+        <p:nvSpPr>
           <p:cNvPr id="9" name="TextBox 8"/>
+          <p:cNvSpPr txBox="1"/>
+          <p:nvPr/>
+        </p:nvSpPr>
+        <p:spPr>
+          <a:xfrm>
+            <a:off x="960120" y="2916936"/>
+            <a:ext cx="10424160" cy="841248"/>
+          </a:xfrm>
+          <a:prstGeom prst="rect">
+            <a:avLst/>
+          </a:prstGeom>
+          <a:noFill/>
+        </p:spPr>
+        <p:txBody>
+          <a:bodyPr wrap="square" anchor="ctr" lIns="0" rIns="0" tIns="0" bIns="0">
+            <a:spAutoFit/>
+          </a:bodyPr>
+          <a:lstStyle/>
+          <a:p>
+            <a:pPr>
+              <a:lnSpc>
+                <a:spcPct val="100000"/>
+              </a:lnSpc>
+            </a:pPr>
+            <a:r>
+              <a:rPr sz="1700" b="0" i="0">
+                <a:solidFill>
+                  <a:srgbClr val="2A2929"/>
+                </a:solidFill>
+                <a:latin typeface="Roboto"/>
+              </a:rPr>
+              <a:t>Trigger plus pre-agreed response, in writing.</a:t>
+            </a:r>
+          </a:p>
+        </p:txBody>
+      </p:sp>
+      <p:sp>
+        <p:nvSpPr>
+          <p:cNvPr id="10" name="Rectangle 9"/>
+          <p:cNvSpPr/>
+          <p:nvPr/>
+        </p:nvSpPr>
+        <p:spPr>
+          <a:xfrm>
+            <a:off x="0" y="6565392"/>
+            <a:ext cx="12191695" cy="38100"/>
+          </a:xfrm>
+          <a:prstGeom prst="rect">
+            <a:avLst/>
+          </a:prstGeom>
+          <a:solidFill>
+            <a:srgbClr val="27B5CE"/>
+          </a:solidFill>
+          <a:ln>
+            <a:noFill/>
+          </a:ln>
+          <a:effectLst/>
+        </p:spPr>
+        <p:style>
+          <a:lnRef idx="1">
+            <a:schemeClr val="accent1"/>
+          </a:lnRef>
+          <a:fillRef idx="3">
+            <a:schemeClr val="accent1"/>
+          </a:fillRef>
+          <a:effectRef idx="2">
+            <a:schemeClr val="accent1"/>
+          </a:effectRef>
+          <a:fontRef idx="minor">
+            <a:schemeClr val="lt1"/>
+          </a:fontRef>
+        </p:style>
+        <p:txBody>
+          <a:bodyPr rtlCol="0" anchor="ctr"/>
+          <a:lstStyle/>
+          <a:p>
+            <a:pPr algn="ctr"/>
+          </a:p>
+        </p:txBody>
+      </p:sp>
+      <p:sp>
+        <p:nvSpPr>
+          <p:cNvPr id="11" name="TextBox 10"/>
           <p:cNvSpPr txBox="1"/>
           <p:nvPr/>
         </p:nvSpPr>
@@ -6190,7 +5619,7 @@
       </p:sp>
       <p:sp>
         <p:nvSpPr>
-          <p:cNvPr id="10" name="TextBox 9"/>
+          <p:cNvPr id="12" name="TextBox 11"/>
           <p:cNvSpPr txBox="1"/>
           <p:nvPr/>
         </p:nvSpPr>
@@ -6218,7 +5647,7 @@
                 </a:solidFill>
                 <a:latin typeface="Roboto"/>
               </a:rPr>
-              <a:t>8</a:t>
+              <a:t>9</a:t>
             </a:r>
           </a:p>
         </p:txBody>
@@ -6264,7 +5693,7 @@
             <a:avLst/>
           </a:prstGeom>
           <a:solidFill>
-            <a:srgbClr val="004488"/>
+            <a:srgbClr val="205F61"/>
           </a:solidFill>
           <a:ln>
             <a:noFill/>
@@ -6322,7 +5751,7 @@
                 </a:solidFill>
                 <a:latin typeface="Roboto"/>
               </a:rPr>
-              <a:t>04</a:t>
+              <a:t>03</a:t>
             </a:r>
           </a:p>
         </p:txBody>
@@ -6352,7 +5781,7 @@
             <a:r>
               <a:rPr sz="1600" b="1" i="0">
                 <a:solidFill>
-                  <a:srgbClr val="004488"/>
+                  <a:srgbClr val="205F61"/>
                 </a:solidFill>
                 <a:latin typeface="Roboto"/>
               </a:rPr>
@@ -6372,7 +5801,7 @@
                 </a:solidFill>
                 <a:latin typeface="Roboto"/>
               </a:rPr>
-              <a:t>Facilitating collaboration</a:t>
+              <a:t>Allocate the work, and agree the outside connections</a:t>
             </a:r>
           </a:p>
           <a:p>
@@ -6388,7 +5817,7 @@
                 </a:solidFill>
                 <a:latin typeface="Roboto Light"/>
               </a:rPr>
-              <a:t>keep the team open, respectful and connected</a:t>
+              <a:t>hand out the boxes, and the seams</a:t>
             </a:r>
           </a:p>
         </p:txBody>
@@ -6408,7 +5837,7 @@
             <a:avLst/>
           </a:prstGeom>
           <a:solidFill>
-            <a:srgbClr val="004488"/>
+            <a:srgbClr val="205F61"/>
           </a:solidFill>
           <a:ln>
             <a:noFill/>
@@ -6570,7 +5999,7 @@
                 </a:solidFill>
                 <a:latin typeface="Roboto"/>
               </a:rPr>
-              <a:t>Facilitation &amp; communication styles</a:t>
+              <a:t>Allocate the four components</a:t>
             </a:r>
           </a:p>
         </p:txBody>
@@ -6590,7 +6019,7 @@
             <a:avLst/>
           </a:prstGeom>
           <a:solidFill>
-            <a:srgbClr val="004488"/>
+            <a:srgbClr val="205F61"/>
           </a:solidFill>
           <a:ln>
             <a:noFill/>
@@ -6627,8 +6056,8 @@
         </p:nvSpPr>
         <p:spPr>
           <a:xfrm>
-            <a:off x="658368" y="1691640"/>
-            <a:ext cx="10881360" cy="4480560"/>
+            <a:off x="658368" y="1737360"/>
+            <a:ext cx="5486400" cy="4297680"/>
           </a:xfrm>
           <a:prstGeom prst="rect">
             <a:avLst/>
@@ -6636,7 +6065,7 @@
           <a:noFill/>
         </p:spPr>
         <p:txBody>
-          <a:bodyPr wrap="square" anchor="ctr" lIns="0" rIns="0" tIns="0" bIns="0">
+          <a:bodyPr wrap="square" anchor="t" lIns="0" rIns="0" tIns="0" bIns="0">
             <a:spAutoFit/>
           </a:bodyPr>
           <a:lstStyle/>
@@ -6653,7 +6082,7 @@
               </a:spcAft>
             </a:pPr>
             <a:r>
-              <a:rPr sz="2400" b="1" i="0">
+              <a:rPr sz="1700" b="1" i="0">
                 <a:solidFill>
                   <a:srgbClr val="EDAB0C"/>
                 </a:solidFill>
@@ -6662,13 +6091,13 @@
               <a:t>■  </a:t>
             </a:r>
             <a:r>
-              <a:rPr sz="2400" b="0" i="0">
+              <a:rPr sz="1700" b="0" i="0">
                 <a:solidFill>
                   <a:srgbClr val="2A2929"/>
                 </a:solidFill>
                 <a:latin typeface="Roboto"/>
               </a:rPr>
-              <a:t>Facilitate open and respectful communication and collaboration between members (PC 2.3).</a:t>
+              <a:t>One component per member — network, compute, database, storage — by expertise or by development potential.</a:t>
             </a:r>
           </a:p>
           <a:p>
@@ -6684,7 +6113,7 @@
               </a:spcAft>
             </a:pPr>
             <a:r>
-              <a:rPr sz="2400" b="1" i="0">
+              <a:rPr sz="1700" b="1" i="0">
                 <a:solidFill>
                   <a:srgbClr val="EDAB0C"/>
                 </a:solidFill>
@@ -6693,13 +6122,13 @@
               <a:t>■  </a:t>
             </a:r>
             <a:r>
-              <a:rPr sz="2400" b="0" i="0">
+              <a:rPr sz="1700" b="0" i="0">
                 <a:solidFill>
                   <a:srgbClr val="2A2929"/>
                 </a:solidFill>
                 <a:latin typeface="Roboto"/>
               </a:rPr>
-              <a:t>Use facilitation techniques that build cohesion and effectiveness — stand-ups, shared review, ground rules (KE 3).</a:t>
+              <a:t>Each allocation carries instruction: the component's scope, the interfaces it must expose, and any contingencies that attach to it.</a:t>
             </a:r>
           </a:p>
           <a:p>
@@ -6715,7 +6144,7 @@
               </a:spcAft>
             </a:pPr>
             <a:r>
-              <a:rPr sz="2400" b="1" i="0">
+              <a:rPr sz="1700" b="1" i="0">
                 <a:solidFill>
                   <a:srgbClr val="EDAB0C"/>
                 </a:solidFill>
@@ -6724,20 +6153,44 @@
               <a:t>■  </a:t>
             </a:r>
             <a:r>
-              <a:rPr sz="2400" b="0" i="0">
+              <a:rPr sz="1700" b="0" i="0">
                 <a:solidFill>
                   <a:srgbClr val="2A2929"/>
                 </a:solidFill>
                 <a:latin typeface="Roboto"/>
               </a:rPr>
-              <a:t>Match the method and style of communication to the message and the person (KE 6) — synchronous for decisions, written for the record.</a:t>
-            </a:r>
-          </a:p>
-        </p:txBody>
-      </p:sp>
-      <p:sp>
-        <p:nvSpPr>
-          <p:cNvPr id="5" name="Rectangle 4"/>
+              <a:t>Allocate the seams, not just the boxes — shared parameters and dependencies are where four components become one build.</a:t>
+            </a:r>
+          </a:p>
+        </p:txBody>
+      </p:sp>
+      <p:pic>
+        <p:nvPicPr>
+          <p:cNvPr id="5" name="Picture 4" descr="component-allocation.png"/>
+          <p:cNvPicPr>
+            <a:picLocks noChangeAspect="1"/>
+          </p:cNvPicPr>
+          <p:nvPr/>
+        </p:nvPicPr>
+        <p:blipFill>
+          <a:blip r:embed="rId2"/>
+          <a:stretch>
+            <a:fillRect/>
+          </a:stretch>
+        </p:blipFill>
+        <p:spPr>
+          <a:xfrm>
+            <a:off x="6400800" y="2811780"/>
+            <a:ext cx="5120640" cy="1965960"/>
+          </a:xfrm>
+          <a:prstGeom prst="rect">
+            <a:avLst/>
+          </a:prstGeom>
+        </p:spPr>
+      </p:pic>
+      <p:sp>
+        <p:nvSpPr>
+          <p:cNvPr id="6" name="Rectangle 5"/>
           <p:cNvSpPr/>
           <p:nvPr/>
         </p:nvSpPr>
@@ -6750,7 +6203,7 @@
             <a:avLst/>
           </a:prstGeom>
           <a:solidFill>
-            <a:srgbClr val="004488"/>
+            <a:srgbClr val="205F61"/>
           </a:solidFill>
           <a:ln>
             <a:noFill/>
@@ -6781,7 +6234,7 @@
       </p:sp>
       <p:sp>
         <p:nvSpPr>
-          <p:cNvPr id="6" name="TextBox 5"/>
+          <p:cNvPr id="7" name="TextBox 6"/>
           <p:cNvSpPr txBox="1"/>
           <p:nvPr/>
         </p:nvSpPr>
@@ -6824,7 +6277,7 @@
       </p:sp>
       <p:sp>
         <p:nvSpPr>
-          <p:cNvPr id="7" name="TextBox 6"/>
+          <p:cNvPr id="8" name="TextBox 7"/>
           <p:cNvSpPr txBox="1"/>
           <p:nvPr/>
         </p:nvSpPr>
@@ -6852,7 +6305,7 @@
                 </a:solidFill>
                 <a:latin typeface="Roboto"/>
               </a:rPr>
-              <a:t>9</a:t>
+              <a:t>10</a:t>
             </a:r>
           </a:p>
         </p:txBody>
@@ -6912,7 +6365,7 @@
                 </a:solidFill>
                 <a:latin typeface="Roboto"/>
               </a:rPr>
-              <a:t>Diverse teams &amp; cross-collaboration</a:t>
+              <a:t>Communicate it, and connect beyond the team</a:t>
             </a:r>
           </a:p>
         </p:txBody>
@@ -6932,7 +6385,7 @@
             <a:avLst/>
           </a:prstGeom>
           <a:solidFill>
-            <a:srgbClr val="004488"/>
+            <a:srgbClr val="205F61"/>
           </a:solidFill>
           <a:ln>
             <a:noFill/>
@@ -7010,7 +6463,7 @@
                 </a:solidFill>
                 <a:latin typeface="Roboto"/>
               </a:rPr>
-              <a:t>Consider the needs of members from diverse backgrounds: apply cross-cultural communication principles and accommodate special needs or disabilities (KE 7, PC 2.3).</a:t>
+              <a:t>Communicate the objectives and responsibilities so everyone shares the same picture of done — confirmed by play-back, not just sent.</a:t>
             </a:r>
           </a:p>
           <a:p>
@@ -7041,7 +6494,7 @@
                 </a:solidFill>
                 <a:latin typeface="Roboto"/>
               </a:rPr>
-              <a:t>Identify opportunities for cross-collaboration with internal and external teams — the DBA team, the security reviewers, an external CloudFormation SME (PC 2.4).</a:t>
+              <a:t>Agree how the team works with people outside it: the internal teams and external specialists worth pulling in, and for what.</a:t>
             </a:r>
           </a:p>
           <a:p>
@@ -7072,7 +6525,7 @@
                 </a:solidFill>
                 <a:latin typeface="Roboto"/>
               </a:rPr>
-              <a:t>Respectful, inclusive facilitation is what makes a four-person split behave as one team.</a:t>
+              <a:t>Facilitation that works for everyone: match the channel to the message, and communicate across cultures and needs.</a:t>
             </a:r>
           </a:p>
         </p:txBody>
@@ -7092,7 +6545,7 @@
             <a:avLst/>
           </a:prstGeom>
           <a:solidFill>
-            <a:srgbClr val="004488"/>
+            <a:srgbClr val="205F61"/>
           </a:solidFill>
           <a:ln>
             <a:noFill/>
@@ -7194,7 +6647,7 @@
                 </a:solidFill>
                 <a:latin typeface="Roboto"/>
               </a:rPr>
-              <a:t>10</a:t>
+              <a:t>11</a:t>
             </a:r>
           </a:p>
         </p:txBody>
@@ -7208,6 +6661,450 @@
 </file>
 
 <file path=ppt/slides/slide16.xml><?xml version="1.0" encoding="utf-8"?>
+<p:sld xmlns:a="http://schemas.openxmlformats.org/drawingml/2006/main" xmlns:p="http://schemas.openxmlformats.org/presentationml/2006/main" xmlns:r="http://schemas.openxmlformats.org/officeDocument/2006/relationships">
+  <p:cSld>
+    <p:bg>
+      <p:bgPr>
+        <a:solidFill>
+          <a:srgbClr val="FFFFFF"/>
+        </a:solidFill>
+        <a:effectLst/>
+      </p:bgPr>
+    </p:bg>
+    <p:spTree>
+      <p:nvGrpSpPr>
+        <p:cNvPr id="1" name=""/>
+        <p:cNvGrpSpPr/>
+        <p:nvPr/>
+      </p:nvGrpSpPr>
+      <p:grpSpPr/>
+      <p:sp>
+        <p:nvSpPr>
+          <p:cNvPr id="2" name="Rectangle 1"/>
+          <p:cNvSpPr/>
+          <p:nvPr/>
+        </p:nvSpPr>
+        <p:spPr>
+          <a:xfrm>
+            <a:off x="0" y="0"/>
+            <a:ext cx="12191695" cy="1234440"/>
+          </a:xfrm>
+          <a:prstGeom prst="rect">
+            <a:avLst/>
+          </a:prstGeom>
+          <a:solidFill>
+            <a:srgbClr val="205F61"/>
+          </a:solidFill>
+          <a:ln>
+            <a:noFill/>
+          </a:ln>
+          <a:effectLst/>
+        </p:spPr>
+        <p:style>
+          <a:lnRef idx="1">
+            <a:schemeClr val="accent1"/>
+          </a:lnRef>
+          <a:fillRef idx="3">
+            <a:schemeClr val="accent1"/>
+          </a:fillRef>
+          <a:effectRef idx="2">
+            <a:schemeClr val="accent1"/>
+          </a:effectRef>
+          <a:fontRef idx="minor">
+            <a:schemeClr val="lt1"/>
+          </a:fontRef>
+        </p:style>
+        <p:txBody>
+          <a:bodyPr rtlCol="0" anchor="ctr"/>
+          <a:lstStyle/>
+          <a:p>
+            <a:pPr algn="ctr"/>
+          </a:p>
+        </p:txBody>
+      </p:sp>
+      <p:sp>
+        <p:nvSpPr>
+          <p:cNvPr id="3" name="Rounded Rectangle 2"/>
+          <p:cNvSpPr/>
+          <p:nvPr/>
+        </p:nvSpPr>
+        <p:spPr>
+          <a:xfrm>
+            <a:off x="640080" y="384048"/>
+            <a:ext cx="1691640" cy="457200"/>
+          </a:xfrm>
+          <a:prstGeom prst="roundRect">
+            <a:avLst/>
+          </a:prstGeom>
+          <a:solidFill>
+            <a:srgbClr val="2A2929"/>
+          </a:solidFill>
+          <a:ln>
+            <a:noFill/>
+          </a:ln>
+          <a:effectLst/>
+        </p:spPr>
+        <p:style>
+          <a:lnRef idx="1">
+            <a:schemeClr val="accent1"/>
+          </a:lnRef>
+          <a:fillRef idx="3">
+            <a:schemeClr val="accent1"/>
+          </a:fillRef>
+          <a:effectRef idx="2">
+            <a:schemeClr val="accent1"/>
+          </a:effectRef>
+          <a:fontRef idx="minor">
+            <a:schemeClr val="lt1"/>
+          </a:fontRef>
+        </p:style>
+        <p:txBody>
+          <a:bodyPr rtlCol="0" anchor="ctr"/>
+          <a:lstStyle/>
+          <a:p>
+            <a:pPr algn="ctr"/>
+            <a:r>
+              <a:rPr sz="1400" b="1" i="0">
+                <a:solidFill>
+                  <a:srgbClr val="FBB900"/>
+                </a:solidFill>
+                <a:latin typeface="Roboto"/>
+              </a:rPr>
+              <a:t>ACTIVITY</a:t>
+            </a:r>
+          </a:p>
+        </p:txBody>
+      </p:sp>
+      <p:sp>
+        <p:nvSpPr>
+          <p:cNvPr id="4" name="TextBox 3"/>
+          <p:cNvSpPr txBox="1"/>
+          <p:nvPr/>
+        </p:nvSpPr>
+        <p:spPr>
+          <a:xfrm>
+            <a:off x="2560320" y="310896"/>
+            <a:ext cx="8961120" cy="685800"/>
+          </a:xfrm>
+          <a:prstGeom prst="rect">
+            <a:avLst/>
+          </a:prstGeom>
+          <a:noFill/>
+        </p:spPr>
+        <p:txBody>
+          <a:bodyPr wrap="square" anchor="ctr" lIns="0" rIns="0" tIns="0" bIns="0">
+            <a:spAutoFit/>
+          </a:bodyPr>
+          <a:lstStyle/>
+          <a:p>
+            <a:r>
+              <a:rPr sz="2600" b="1" i="0">
+                <a:solidFill>
+                  <a:srgbClr val="FFFFFF"/>
+                </a:solidFill>
+                <a:latin typeface="Roboto"/>
+              </a:rPr>
+              <a:t>Allocate and agree</a:t>
+            </a:r>
+          </a:p>
+        </p:txBody>
+      </p:sp>
+      <p:sp>
+        <p:nvSpPr>
+          <p:cNvPr id="5" name="TextBox 4"/>
+          <p:cNvSpPr txBox="1"/>
+          <p:nvPr/>
+        </p:nvSpPr>
+        <p:spPr>
+          <a:xfrm>
+            <a:off x="658368" y="1554480"/>
+            <a:ext cx="10881360" cy="4297680"/>
+          </a:xfrm>
+          <a:prstGeom prst="rect">
+            <a:avLst/>
+          </a:prstGeom>
+          <a:noFill/>
+        </p:spPr>
+        <p:txBody>
+          <a:bodyPr wrap="square" anchor="t" lIns="0" rIns="0" tIns="0" bIns="0">
+            <a:spAutoFit/>
+          </a:bodyPr>
+          <a:lstStyle/>
+          <a:p>
+            <a:pPr marL="0" indent="0">
+              <a:lnSpc>
+                <a:spcPct val="105000"/>
+              </a:lnSpc>
+              <a:spcBef>
+                <a:spcPts val="0"/>
+              </a:spcBef>
+              <a:spcAft>
+                <a:spcPts val="1000"/>
+              </a:spcAft>
+            </a:pPr>
+            <a:r>
+              <a:rPr sz="1700" b="1" i="0">
+                <a:solidFill>
+                  <a:srgbClr val="EDAB0C"/>
+                </a:solidFill>
+                <a:latin typeface="Roboto"/>
+              </a:rPr>
+              <a:t>■  </a:t>
+            </a:r>
+            <a:r>
+              <a:rPr sz="1700" b="0" i="0">
+                <a:solidFill>
+                  <a:srgbClr val="2A2929"/>
+                </a:solidFill>
+                <a:latin typeface="Roboto"/>
+              </a:rPr>
+              <a:t>Workbook — tasks 5 and 6.</a:t>
+            </a:r>
+          </a:p>
+          <a:p>
+            <a:pPr marL="0" indent="0">
+              <a:lnSpc>
+                <a:spcPct val="105000"/>
+              </a:lnSpc>
+              <a:spcBef>
+                <a:spcPts val="0"/>
+              </a:spcBef>
+              <a:spcAft>
+                <a:spcPts val="1000"/>
+              </a:spcAft>
+            </a:pPr>
+            <a:r>
+              <a:rPr sz="1700" b="1" i="0">
+                <a:solidFill>
+                  <a:srgbClr val="EDAB0C"/>
+                </a:solidFill>
+                <a:latin typeface="Roboto"/>
+              </a:rPr>
+              <a:t>■  </a:t>
+            </a:r>
+            <a:r>
+              <a:rPr sz="1700" b="0" i="0">
+                <a:solidFill>
+                  <a:srgbClr val="2A2929"/>
+                </a:solidFill>
+                <a:latin typeface="Roboto"/>
+              </a:rPr>
+              <a:t>Allocate the four components with instruction and seams, then agree how the team will work with people outside it.</a:t>
+            </a:r>
+          </a:p>
+        </p:txBody>
+      </p:sp>
+      <p:sp>
+        <p:nvSpPr>
+          <p:cNvPr id="6" name="Rounded Rectangle 5"/>
+          <p:cNvSpPr/>
+          <p:nvPr/>
+        </p:nvSpPr>
+        <p:spPr>
+          <a:xfrm>
+            <a:off x="640080" y="5897880"/>
+            <a:ext cx="4023360" cy="457200"/>
+          </a:xfrm>
+          <a:prstGeom prst="roundRect">
+            <a:avLst/>
+          </a:prstGeom>
+          <a:solidFill>
+            <a:srgbClr val="F9F9F9"/>
+          </a:solidFill>
+          <a:ln w="12700">
+            <a:solidFill>
+              <a:srgbClr val="CCCCCC"/>
+            </a:solidFill>
+          </a:ln>
+          <a:effectLst/>
+        </p:spPr>
+        <p:style>
+          <a:lnRef idx="1">
+            <a:schemeClr val="accent1"/>
+          </a:lnRef>
+          <a:fillRef idx="3">
+            <a:schemeClr val="accent1"/>
+          </a:fillRef>
+          <a:effectRef idx="2">
+            <a:schemeClr val="accent1"/>
+          </a:effectRef>
+          <a:fontRef idx="minor">
+            <a:schemeClr val="lt1"/>
+          </a:fontRef>
+        </p:style>
+        <p:txBody>
+          <a:bodyPr rtlCol="0" anchor="ctr"/>
+          <a:lstStyle/>
+          <a:p>
+            <a:pPr algn="ctr"/>
+          </a:p>
+        </p:txBody>
+      </p:sp>
+      <p:sp>
+        <p:nvSpPr>
+          <p:cNvPr id="7" name="TextBox 6"/>
+          <p:cNvSpPr txBox="1"/>
+          <p:nvPr/>
+        </p:nvSpPr>
+        <p:spPr>
+          <a:xfrm>
+            <a:off x="822960" y="5943600"/>
+            <a:ext cx="3657600" cy="365760"/>
+          </a:xfrm>
+          <a:prstGeom prst="rect">
+            <a:avLst/>
+          </a:prstGeom>
+          <a:noFill/>
+        </p:spPr>
+        <p:txBody>
+          <a:bodyPr wrap="square" anchor="ctr" lIns="0" rIns="0" tIns="0" bIns="0">
+            <a:spAutoFit/>
+          </a:bodyPr>
+          <a:lstStyle/>
+          <a:p>
+            <a:r>
+              <a:rPr sz="1500" b="1" i="0">
+                <a:solidFill>
+                  <a:srgbClr val="2A2929"/>
+                </a:solidFill>
+                <a:latin typeface="Roboto"/>
+              </a:rPr>
+              <a:t>⏱  ~30 min</a:t>
+            </a:r>
+          </a:p>
+        </p:txBody>
+      </p:sp>
+      <p:sp>
+        <p:nvSpPr>
+          <p:cNvPr id="8" name="Rectangle 7"/>
+          <p:cNvSpPr/>
+          <p:nvPr/>
+        </p:nvSpPr>
+        <p:spPr>
+          <a:xfrm>
+            <a:off x="0" y="6565392"/>
+            <a:ext cx="12191695" cy="38100"/>
+          </a:xfrm>
+          <a:prstGeom prst="rect">
+            <a:avLst/>
+          </a:prstGeom>
+          <a:solidFill>
+            <a:srgbClr val="205F61"/>
+          </a:solidFill>
+          <a:ln>
+            <a:noFill/>
+          </a:ln>
+          <a:effectLst/>
+        </p:spPr>
+        <p:style>
+          <a:lnRef idx="1">
+            <a:schemeClr val="accent1"/>
+          </a:lnRef>
+          <a:fillRef idx="3">
+            <a:schemeClr val="accent1"/>
+          </a:fillRef>
+          <a:effectRef idx="2">
+            <a:schemeClr val="accent1"/>
+          </a:effectRef>
+          <a:fontRef idx="minor">
+            <a:schemeClr val="lt1"/>
+          </a:fontRef>
+        </p:style>
+        <p:txBody>
+          <a:bodyPr rtlCol="0" anchor="ctr"/>
+          <a:lstStyle/>
+          <a:p>
+            <a:pPr algn="ctr"/>
+          </a:p>
+        </p:txBody>
+      </p:sp>
+      <p:sp>
+        <p:nvSpPr>
+          <p:cNvPr id="9" name="TextBox 8"/>
+          <p:cNvSpPr txBox="1"/>
+          <p:nvPr/>
+        </p:nvSpPr>
+        <p:spPr>
+          <a:xfrm>
+            <a:off x="502920" y="6400800"/>
+            <a:ext cx="5486400" cy="320040"/>
+          </a:xfrm>
+          <a:prstGeom prst="rect">
+            <a:avLst/>
+          </a:prstGeom>
+          <a:noFill/>
+        </p:spPr>
+        <p:txBody>
+          <a:bodyPr wrap="square" anchor="t" lIns="0" rIns="0" tIns="0" bIns="0">
+            <a:spAutoFit/>
+          </a:bodyPr>
+          <a:lstStyle/>
+          <a:p>
+            <a:r>
+              <a:rPr sz="1100" b="1" i="0">
+                <a:solidFill>
+                  <a:srgbClr val="2A2929"/>
+                </a:solidFill>
+                <a:latin typeface="Roboto"/>
+              </a:rPr>
+              <a:t>Kangan </a:t>
+            </a:r>
+            <a:r>
+              <a:rPr sz="1100" b="1" i="0">
+                <a:solidFill>
+                  <a:srgbClr val="D68E10"/>
+                </a:solidFill>
+                <a:latin typeface="Roboto"/>
+              </a:rPr>
+              <a:t>Institute</a:t>
+            </a:r>
+          </a:p>
+        </p:txBody>
+      </p:sp>
+      <p:sp>
+        <p:nvSpPr>
+          <p:cNvPr id="10" name="TextBox 9"/>
+          <p:cNvSpPr txBox="1"/>
+          <p:nvPr/>
+        </p:nvSpPr>
+        <p:spPr>
+          <a:xfrm>
+            <a:off x="10515600" y="6400800"/>
+            <a:ext cx="1188720" cy="320040"/>
+          </a:xfrm>
+          <a:prstGeom prst="rect">
+            <a:avLst/>
+          </a:prstGeom>
+          <a:noFill/>
+        </p:spPr>
+        <p:txBody>
+          <a:bodyPr wrap="square" anchor="t" lIns="0" rIns="0" tIns="0" bIns="0">
+            <a:spAutoFit/>
+          </a:bodyPr>
+          <a:lstStyle/>
+          <a:p>
+            <a:pPr algn="r"/>
+            <a:r>
+              <a:rPr sz="1100" b="0" i="0">
+                <a:solidFill>
+                  <a:srgbClr val="7A7A7A"/>
+                </a:solidFill>
+                <a:latin typeface="Roboto"/>
+              </a:rPr>
+              <a:t>12</a:t>
+            </a:r>
+          </a:p>
+        </p:txBody>
+      </p:sp>
+    </p:spTree>
+  </p:cSld>
+  <p:clrMapOvr>
+    <a:masterClrMapping/>
+  </p:clrMapOvr>
+</p:sld>
+</file>
+
+<file path=ppt/slides/slide17.xml><?xml version="1.0" encoding="utf-8"?>
 <p:sld xmlns:a="http://schemas.openxmlformats.org/drawingml/2006/main" xmlns:p="http://schemas.openxmlformats.org/presentationml/2006/main" xmlns:r="http://schemas.openxmlformats.org/officeDocument/2006/relationships">
   <p:cSld>
     <p:bg>
@@ -7266,7 +7163,7 @@
             <a:r>
               <a:rPr sz="1800" b="1" i="0">
                 <a:solidFill>
-                  <a:srgbClr val="004488"/>
+                  <a:srgbClr val="205F61"/>
                 </a:solidFill>
                 <a:latin typeface="Roboto"/>
               </a:rPr>
@@ -7290,7 +7187,7 @@
             <a:avLst/>
           </a:prstGeom>
           <a:solidFill>
-            <a:srgbClr val="004488"/>
+            <a:srgbClr val="205F61"/>
           </a:solidFill>
           <a:ln>
             <a:noFill/>
@@ -7380,7 +7277,7 @@
             <a:avLst/>
           </a:prstGeom>
           <a:solidFill>
-            <a:srgbClr val="004488"/>
+            <a:srgbClr val="205F61"/>
           </a:solidFill>
           <a:ln>
             <a:noFill/>
@@ -7443,7 +7340,7 @@
                 </a:solidFill>
                 <a:latin typeface="Roboto"/>
               </a:rPr>
-              <a:t>Name the common objective, set per-member performance plans, and choose accountability strategies grounded in policy and law.</a:t>
+              <a:t>Objective, expectations, accountability, contingencies — the team plan.</a:t>
             </a:r>
           </a:p>
         </p:txBody>
@@ -7509,7 +7406,7 @@
             <a:avLst/>
           </a:prstGeom>
           <a:solidFill>
-            <a:srgbClr val="004488"/>
+            <a:srgbClr val="205F61"/>
           </a:solidFill>
           <a:ln>
             <a:noFill/>
@@ -7572,7 +7469,7 @@
                 </a:solidFill>
                 <a:latin typeface="Roboto"/>
               </a:rPr>
-              <a:t>Plan for the typical contingencies — absence, re-allocation, succession — before the build starts.</a:t>
+              <a:t>Four components allocated with instruction; the seams allocated too.</a:t>
             </a:r>
           </a:p>
         </p:txBody>
@@ -7638,7 +7535,7 @@
             <a:avLst/>
           </a:prstGeom>
           <a:solidFill>
-            <a:srgbClr val="004488"/>
+            <a:srgbClr val="205F61"/>
           </a:solidFill>
           <a:ln>
             <a:noFill/>
@@ -7701,7 +7598,7 @@
                 </a:solidFill>
                 <a:latin typeface="Roboto"/>
               </a:rPr>
-              <a:t>Communicate the objective, then allocate the four components one per member with clear instruction.</a:t>
+              <a:t>Outside connections agreed before they're needed.</a:t>
             </a:r>
           </a:p>
         </p:txBody>
@@ -7714,19 +7611,17 @@
         </p:nvSpPr>
         <p:spPr>
           <a:xfrm>
-            <a:off x="640080" y="4818888"/>
-            <a:ext cx="10927080" cy="841248"/>
+            <a:off x="0" y="6565392"/>
+            <a:ext cx="12191695" cy="38100"/>
           </a:xfrm>
           <a:prstGeom prst="rect">
             <a:avLst/>
           </a:prstGeom>
           <a:solidFill>
-            <a:srgbClr val="FFFFFF"/>
+            <a:srgbClr val="205F61"/>
           </a:solidFill>
-          <a:ln w="12700">
-            <a:solidFill>
-              <a:srgbClr val="CCCCCC"/>
-            </a:solidFill>
+          <a:ln>
+            <a:noFill/>
           </a:ln>
           <a:effectLst/>
         </p:spPr>
@@ -7754,134 +7649,7 @@
       </p:sp>
       <p:sp>
         <p:nvSpPr>
-          <p:cNvPr id="14" name="Rectangle 13"/>
-          <p:cNvSpPr/>
-          <p:nvPr/>
-        </p:nvSpPr>
-        <p:spPr>
-          <a:xfrm>
-            <a:off x="640080" y="4818888"/>
-            <a:ext cx="109728" cy="841248"/>
-          </a:xfrm>
-          <a:prstGeom prst="rect">
-            <a:avLst/>
-          </a:prstGeom>
-          <a:solidFill>
-            <a:srgbClr val="004488"/>
-          </a:solidFill>
-          <a:ln>
-            <a:noFill/>
-          </a:ln>
-          <a:effectLst/>
-        </p:spPr>
-        <p:style>
-          <a:lnRef idx="1">
-            <a:schemeClr val="accent1"/>
-          </a:lnRef>
-          <a:fillRef idx="3">
-            <a:schemeClr val="accent1"/>
-          </a:fillRef>
-          <a:effectRef idx="2">
-            <a:schemeClr val="accent1"/>
-          </a:effectRef>
-          <a:fontRef idx="minor">
-            <a:schemeClr val="lt1"/>
-          </a:fontRef>
-        </p:style>
-        <p:txBody>
-          <a:bodyPr rtlCol="0" anchor="ctr"/>
-          <a:lstStyle/>
-          <a:p>
-            <a:pPr algn="ctr"/>
-          </a:p>
-        </p:txBody>
-      </p:sp>
-      <p:sp>
-        <p:nvSpPr>
-          <p:cNvPr id="15" name="TextBox 14"/>
-          <p:cNvSpPr txBox="1"/>
-          <p:nvPr/>
-        </p:nvSpPr>
-        <p:spPr>
-          <a:xfrm>
-            <a:off x="960120" y="4818888"/>
-            <a:ext cx="10424160" cy="841248"/>
-          </a:xfrm>
-          <a:prstGeom prst="rect">
-            <a:avLst/>
-          </a:prstGeom>
-          <a:noFill/>
-        </p:spPr>
-        <p:txBody>
-          <a:bodyPr wrap="square" anchor="ctr" lIns="0" rIns="0" tIns="0" bIns="0">
-            <a:spAutoFit/>
-          </a:bodyPr>
-          <a:lstStyle/>
-          <a:p>
-            <a:pPr>
-              <a:lnSpc>
-                <a:spcPct val="100000"/>
-              </a:lnSpc>
-            </a:pPr>
-            <a:r>
-              <a:rPr sz="1700" b="0" i="0">
-                <a:solidFill>
-                  <a:srgbClr val="2A2929"/>
-                </a:solidFill>
-                <a:latin typeface="Roboto"/>
-              </a:rPr>
-              <a:t>Facilitate open, respectful, inclusive collaboration and connect with internal/external teams.</a:t>
-            </a:r>
-          </a:p>
-        </p:txBody>
-      </p:sp>
-      <p:sp>
-        <p:nvSpPr>
-          <p:cNvPr id="16" name="Rectangle 15"/>
-          <p:cNvSpPr/>
-          <p:nvPr/>
-        </p:nvSpPr>
-        <p:spPr>
-          <a:xfrm>
-            <a:off x="0" y="6565392"/>
-            <a:ext cx="12191695" cy="38100"/>
-          </a:xfrm>
-          <a:prstGeom prst="rect">
-            <a:avLst/>
-          </a:prstGeom>
-          <a:solidFill>
-            <a:srgbClr val="004488"/>
-          </a:solidFill>
-          <a:ln>
-            <a:noFill/>
-          </a:ln>
-          <a:effectLst/>
-        </p:spPr>
-        <p:style>
-          <a:lnRef idx="1">
-            <a:schemeClr val="accent1"/>
-          </a:lnRef>
-          <a:fillRef idx="3">
-            <a:schemeClr val="accent1"/>
-          </a:fillRef>
-          <a:effectRef idx="2">
-            <a:schemeClr val="accent1"/>
-          </a:effectRef>
-          <a:fontRef idx="minor">
-            <a:schemeClr val="lt1"/>
-          </a:fontRef>
-        </p:style>
-        <p:txBody>
-          <a:bodyPr rtlCol="0" anchor="ctr"/>
-          <a:lstStyle/>
-          <a:p>
-            <a:pPr algn="ctr"/>
-          </a:p>
-        </p:txBody>
-      </p:sp>
-      <p:sp>
-        <p:nvSpPr>
-          <p:cNvPr id="17" name="TextBox 16"/>
+          <p:cNvPr id="14" name="TextBox 13"/>
           <p:cNvSpPr txBox="1"/>
           <p:nvPr/>
         </p:nvSpPr>
@@ -7924,7 +7692,7 @@
       </p:sp>
       <p:sp>
         <p:nvSpPr>
-          <p:cNvPr id="18" name="TextBox 17"/>
+          <p:cNvPr id="15" name="TextBox 14"/>
           <p:cNvSpPr txBox="1"/>
           <p:nvPr/>
         </p:nvSpPr>
@@ -7952,7 +7720,7 @@
                 </a:solidFill>
                 <a:latin typeface="Roboto"/>
               </a:rPr>
-              <a:t>11</a:t>
+              <a:t>13</a:t>
             </a:r>
           </a:p>
         </p:txBody>
@@ -7965,7 +7733,7 @@
 </p:sld>
 </file>
 
-<file path=ppt/slides/slide17.xml><?xml version="1.0" encoding="utf-8"?>
+<file path=ppt/slides/slide18.xml><?xml version="1.0" encoding="utf-8"?>
 <p:sld xmlns:a="http://schemas.openxmlformats.org/drawingml/2006/main" xmlns:p="http://schemas.openxmlformats.org/presentationml/2006/main" xmlns:r="http://schemas.openxmlformats.org/officeDocument/2006/relationships">
   <p:cSld>
     <p:bg>
@@ -8056,7 +7824,7 @@
                 </a:solidFill>
                 <a:latin typeface="Roboto"/>
               </a:rPr>
-              <a:t>Next: Topic 6 — lead the team through the build</a:t>
+              <a:t>Next: Topic 6 — leading the build</a:t>
             </a:r>
           </a:p>
           <a:p>
@@ -8075,7 +7843,7 @@
                 </a:solidFill>
                 <a:latin typeface="Roboto Light"/>
               </a:rPr>
-              <a:t>You've planned the team and allocated the four components; next you lead, support and monitor them as they write the IaC.</a:t>
+              <a:t>The team is stood up: objective agreed, work allocated, trouble planned for.</a:t>
             </a:r>
           </a:p>
           <a:p>
@@ -8094,7 +7862,7 @@
                 </a:solidFill>
                 <a:latin typeface="Roboto Light"/>
               </a:rPr>
-              <a:t>Bring the team plan and allocations — Topic 6 runs the build against them.</a:t>
+              <a:t>Next the build runs — and you lead it: the meeting, the coaching, the measuring, the reflecting.</a:t>
             </a:r>
           </a:p>
         </p:txBody>
@@ -8252,7 +8020,7 @@
                 </a:solidFill>
                 <a:latin typeface="Roboto"/>
               </a:rPr>
-              <a:t>Topic 5 opens AT2: the approved design is written as CloudFormation by a team of four, one IaC component each — network, compute, database, storage.</a:t>
+              <a:t>AT2 begins: the approved design is written as CloudFormation by a team of four, one component each — network, compute, database, storage.</a:t>
             </a:r>
           </a:p>
           <a:p>
@@ -8283,7 +8051,7 @@
                 </a:solidFill>
                 <a:latin typeface="Roboto"/>
               </a:rPr>
-              <a:t>Dividing the write is the leadership vehicle: you plan the team, set expectations, and allocate the work — the write itself is a 504 concern, not assessed here.</a:t>
+              <a:t>Dividing the write is the leadership vehicle: what is marked is how you plan, allocate and lead — not the code.</a:t>
             </a:r>
           </a:p>
           <a:p>
@@ -8314,38 +8082,7 @@
                 </a:solidFill>
                 <a:latin typeface="Roboto"/>
               </a:rPr>
-              <a:t>This Topic is the set-up half of AT2 (plan and stand up the team); leading them through the write is Topic 6.</a:t>
-            </a:r>
-          </a:p>
-          <a:p>
-            <a:pPr marL="0" indent="0">
-              <a:lnSpc>
-                <a:spcPct val="105000"/>
-              </a:lnSpc>
-              <a:spcBef>
-                <a:spcPts val="0"/>
-              </a:spcBef>
-              <a:spcAft>
-                <a:spcPts val="1000"/>
-              </a:spcAft>
-            </a:pPr>
-            <a:r>
-              <a:rPr sz="1700" b="1" i="0">
-                <a:solidFill>
-                  <a:srgbClr val="EDAB0C"/>
-                </a:solidFill>
-                <a:latin typeface="Roboto"/>
-              </a:rPr>
-              <a:t>■  </a:t>
-            </a:r>
-            <a:r>
-              <a:rPr sz="1700" b="0" i="0">
-                <a:solidFill>
-                  <a:srgbClr val="2A2929"/>
-                </a:solidFill>
-                <a:latin typeface="Roboto"/>
-              </a:rPr>
-              <a:t>In-world, the team is YAT ICT staff improving Ledgerline.</a:t>
+              <a:t>This Topic stands the team up; leading it through the build is Topic 6.</a:t>
             </a:r>
           </a:p>
         </p:txBody>
@@ -8645,7 +8382,7 @@
                 </a:solidFill>
                 <a:latin typeface="Roboto"/>
               </a:rPr>
-              <a:t>Objectives, performance plans &amp; accountability</a:t>
+              <a:t>The objective, the expectations, the accountability</a:t>
             </a:r>
           </a:p>
           <a:p>
@@ -8843,7 +8580,7 @@
                 </a:solidFill>
                 <a:latin typeface="Roboto"/>
               </a:rPr>
-              <a:t>Team objectives, responsibilities &amp; outcomes</a:t>
+              <a:t>Agree what the team is here to do</a:t>
             </a:r>
           </a:p>
         </p:txBody>
@@ -8941,7 +8678,7 @@
                 </a:solidFill>
                 <a:latin typeface="Roboto"/>
               </a:rPr>
-              <a:t>Start by naming the common objective: deliver the approved Ledgerline design as working, deployed IaC.</a:t>
+              <a:t>Name the common objective out loud — everyone should be able to recite it the same way.</a:t>
             </a:r>
           </a:p>
           <a:p>
@@ -8972,7 +8709,7 @@
                 </a:solidFill>
                 <a:latin typeface="Roboto"/>
               </a:rPr>
-              <a:t>Break it into responsibilities and required outcomes — what the team must produce, and to what standard.</a:t>
+              <a:t>Break it into responsibilities and required outcomes: what the team must produce, to what standard.</a:t>
             </a:r>
           </a:p>
           <a:p>
@@ -9185,7 +8922,7 @@
                 </a:solidFill>
                 <a:latin typeface="Roboto"/>
               </a:rPr>
-              <a:t>Performance plans set expectations</a:t>
+              <a:t>Set what is expected of each member</a:t>
             </a:r>
           </a:p>
         </p:txBody>
@@ -9283,7 +9020,7 @@
                 </a:solidFill>
                 <a:latin typeface="Roboto"/>
               </a:rPr>
-              <a:t>A performance plan sets each member's expected outcomes, goals and behaviours for their component.</a:t>
+              <a:t>A performance plan per member: expected outcomes, goals and behaviours for their component — measurable, not a pep talk.</a:t>
             </a:r>
           </a:p>
           <a:p>
@@ -9314,7 +9051,7 @@
                 </a:solidFill>
                 <a:latin typeface="Roboto"/>
               </a:rPr>
-              <a:t>Align each plan to the team objective and to relevant policies — a plan is not a wish-list, it is measurable.</a:t>
+              <a:t>Align each plan to the team objective and to the organisation's policies.</a:t>
             </a:r>
           </a:p>
           <a:p>
@@ -9345,7 +9082,7 @@
                 </a:solidFill>
                 <a:latin typeface="Roboto"/>
               </a:rPr>
-              <a:t>Example: "network component templates valid, peer-reviewed and deployed to us-east-1 by the milestone; collaborates on shared parameters."</a:t>
+              <a:t>The shape: an outcome, a standard, a deadline, and a collaboration behaviour.</a:t>
             </a:r>
           </a:p>
         </p:txBody>
@@ -9527,7 +9264,7 @@
                 </a:solidFill>
                 <a:latin typeface="Roboto"/>
               </a:rPr>
-              <a:t>Accountability, grounded in organisational &amp; legislative requirements</a:t>
+              <a:t>Agree how you hold each other accountable</a:t>
             </a:r>
           </a:p>
         </p:txBody>
@@ -9625,7 +9362,7 @@
                 </a:solidFill>
                 <a:latin typeface="Roboto"/>
               </a:rPr>
-              <a:t>Choose accountability strategies: clear ownership per component, review checkpoints, a shared definition of done.</a:t>
+              <a:t>Concrete mechanisms: clear ownership per component, review checkpoints, a shared definition of done.</a:t>
             </a:r>
           </a:p>
           <a:p>
@@ -9656,7 +9393,7 @@
                 </a:solidFill>
                 <a:latin typeface="Roboto"/>
               </a:rPr>
-              <a:t>Ground them in organisational requirements — workplace policies, codes of conduct, and YAT's reputation and culture (KE 1).</a:t>
+              <a:t>Grounded in organisational requirements — policies, codes of conduct, the organisation's culture — and inside the legislative ones: health and safety, privacy, anti-discrimination.</a:t>
             </a:r>
           </a:p>
           <a:p>
@@ -9687,7 +9424,7 @@
                 </a:solidFill>
                 <a:latin typeface="Roboto"/>
               </a:rPr>
-              <a:t>Respect the legislative requirements relevant to the workplace (work health &amp; safety, privacy, anti-discrimination) (KE 2) — accountability operates inside those rules.</a:t>
+              <a:t>Accountability is preventive structure, not blame after the fact.</a:t>
             </a:r>
           </a:p>
         </p:txBody>
@@ -9849,13 +9586,13 @@
         <p:spPr>
           <a:xfrm>
             <a:off x="0" y="0"/>
-            <a:ext cx="3931920" cy="6858000"/>
+            <a:ext cx="12191695" cy="1234440"/>
           </a:xfrm>
           <a:prstGeom prst="rect">
             <a:avLst/>
           </a:prstGeom>
           <a:solidFill>
-            <a:srgbClr val="27B5CE"/>
+            <a:srgbClr val="92268F"/>
           </a:solidFill>
           <a:ln>
             <a:noFill/>
@@ -9886,120 +9623,20 @@
       </p:sp>
       <p:sp>
         <p:nvSpPr>
-          <p:cNvPr id="3" name="TextBox 2"/>
-          <p:cNvSpPr txBox="1"/>
-          <p:nvPr/>
-        </p:nvSpPr>
-        <p:spPr>
-          <a:xfrm>
-            <a:off x="365760" y="2103120"/>
-            <a:ext cx="3291840" cy="2194560"/>
-          </a:xfrm>
-          <a:prstGeom prst="rect">
-            <a:avLst/>
-          </a:prstGeom>
-          <a:noFill/>
-        </p:spPr>
-        <p:txBody>
-          <a:bodyPr wrap="square" anchor="t" lIns="0" rIns="0" tIns="0" bIns="0">
-            <a:spAutoFit/>
-          </a:bodyPr>
-          <a:lstStyle/>
-          <a:p>
-            <a:r>
-              <a:rPr sz="13000" b="1" i="0">
-                <a:solidFill>
-                  <a:srgbClr val="FFFFFF"/>
-                </a:solidFill>
-                <a:latin typeface="Roboto"/>
-              </a:rPr>
-              <a:t>02</a:t>
-            </a:r>
-          </a:p>
-        </p:txBody>
-      </p:sp>
-      <p:sp>
-        <p:nvSpPr>
-          <p:cNvPr id="4" name="TextBox 3"/>
-          <p:cNvSpPr txBox="1"/>
-          <p:nvPr/>
-        </p:nvSpPr>
-        <p:spPr>
-          <a:xfrm>
-            <a:off x="4480560" y="2468880"/>
-            <a:ext cx="7132320" cy="2194560"/>
-          </a:xfrm>
-          <a:prstGeom prst="rect">
-            <a:avLst/>
-          </a:prstGeom>
-          <a:noFill/>
-        </p:spPr>
-        <p:txBody>
-          <a:bodyPr wrap="square" anchor="t" lIns="0" rIns="0" tIns="0" bIns="0">
-            <a:spAutoFit/>
-          </a:bodyPr>
-          <a:lstStyle/>
-          <a:p>
-            <a:r>
-              <a:rPr sz="1600" b="1" i="0">
-                <a:solidFill>
-                  <a:srgbClr val="27B5CE"/>
-                </a:solidFill>
-                <a:latin typeface="Roboto"/>
-              </a:rPr>
-              <a:t>SECTION</a:t>
-            </a:r>
-          </a:p>
-          <a:p>
-            <a:pPr>
-              <a:spcBef>
-                <a:spcPts val="600"/>
-              </a:spcBef>
-            </a:pPr>
-            <a:r>
-              <a:rPr sz="3800" b="1" i="0">
-                <a:solidFill>
-                  <a:srgbClr val="2A2929"/>
-                </a:solidFill>
-                <a:latin typeface="Roboto"/>
-              </a:rPr>
-              <a:t>Contingency planning</a:t>
-            </a:r>
-          </a:p>
-          <a:p>
-            <a:pPr>
-              <a:spcBef>
-                <a:spcPts val="1000"/>
-              </a:spcBef>
-            </a:pPr>
-            <a:r>
-              <a:rPr sz="2000" b="0" i="1">
-                <a:solidFill>
-                  <a:srgbClr val="484848"/>
-                </a:solidFill>
-                <a:latin typeface="Roboto Light"/>
-              </a:rPr>
-              <a:t>plan for the things that go wrong</a:t>
-            </a:r>
-          </a:p>
-        </p:txBody>
-      </p:sp>
-      <p:sp>
-        <p:nvSpPr>
-          <p:cNvPr id="5" name="Rectangle 4"/>
+          <p:cNvPr id="3" name="Rounded Rectangle 2"/>
           <p:cNvSpPr/>
           <p:nvPr/>
         </p:nvSpPr>
         <p:spPr>
           <a:xfrm>
-            <a:off x="0" y="6565392"/>
-            <a:ext cx="12191695" cy="38100"/>
-          </a:xfrm>
-          <a:prstGeom prst="rect">
+            <a:off x="640080" y="384048"/>
+            <a:ext cx="1691640" cy="457200"/>
+          </a:xfrm>
+          <a:prstGeom prst="roundRect">
             <a:avLst/>
           </a:prstGeom>
           <a:solidFill>
-            <a:srgbClr val="27B5CE"/>
+            <a:srgbClr val="2A2929"/>
           </a:solidFill>
           <a:ln>
             <a:noFill/>
@@ -10025,19 +9662,62 @@
           <a:lstStyle/>
           <a:p>
             <a:pPr algn="ctr"/>
-          </a:p>
-        </p:txBody>
-      </p:sp>
-      <p:sp>
-        <p:nvSpPr>
-          <p:cNvPr id="6" name="TextBox 5"/>
+            <a:r>
+              <a:rPr sz="1400" b="1" i="0">
+                <a:solidFill>
+                  <a:srgbClr val="FBB900"/>
+                </a:solidFill>
+                <a:latin typeface="Roboto"/>
+              </a:rPr>
+              <a:t>ACTIVITY</a:t>
+            </a:r>
+          </a:p>
+        </p:txBody>
+      </p:sp>
+      <p:sp>
+        <p:nvSpPr>
+          <p:cNvPr id="4" name="TextBox 3"/>
           <p:cNvSpPr txBox="1"/>
           <p:nvPr/>
         </p:nvSpPr>
         <p:spPr>
           <a:xfrm>
-            <a:off x="502920" y="6400800"/>
-            <a:ext cx="5486400" cy="320040"/>
+            <a:off x="2560320" y="310896"/>
+            <a:ext cx="8961120" cy="685800"/>
+          </a:xfrm>
+          <a:prstGeom prst="rect">
+            <a:avLst/>
+          </a:prstGeom>
+          <a:noFill/>
+        </p:spPr>
+        <p:txBody>
+          <a:bodyPr wrap="square" anchor="ctr" lIns="0" rIns="0" tIns="0" bIns="0">
+            <a:spAutoFit/>
+          </a:bodyPr>
+          <a:lstStyle/>
+          <a:p>
+            <a:r>
+              <a:rPr sz="2600" b="1" i="0">
+                <a:solidFill>
+                  <a:srgbClr val="FFFFFF"/>
+                </a:solidFill>
+                <a:latin typeface="Roboto"/>
+              </a:rPr>
+              <a:t>Stand the team up</a:t>
+            </a:r>
+          </a:p>
+        </p:txBody>
+      </p:sp>
+      <p:sp>
+        <p:nvSpPr>
+          <p:cNvPr id="5" name="TextBox 4"/>
+          <p:cNvSpPr txBox="1"/>
+          <p:nvPr/>
+        </p:nvSpPr>
+        <p:spPr>
+          <a:xfrm>
+            <a:off x="658368" y="1554480"/>
+            <a:ext cx="10881360" cy="4297680"/>
           </a:xfrm>
           <a:prstGeom prst="rect">
             <a:avLst/>
@@ -10050,24 +9730,112 @@
           </a:bodyPr>
           <a:lstStyle/>
           <a:p>
-            <a:r>
-              <a:rPr sz="1100" b="1" i="0">
+            <a:pPr marL="0" indent="0">
+              <a:lnSpc>
+                <a:spcPct val="105000"/>
+              </a:lnSpc>
+              <a:spcBef>
+                <a:spcPts val="0"/>
+              </a:spcBef>
+              <a:spcAft>
+                <a:spcPts val="1000"/>
+              </a:spcAft>
+            </a:pPr>
+            <a:r>
+              <a:rPr sz="1700" b="1" i="0">
+                <a:solidFill>
+                  <a:srgbClr val="EDAB0C"/>
+                </a:solidFill>
+                <a:latin typeface="Roboto"/>
+              </a:rPr>
+              <a:t>■  </a:t>
+            </a:r>
+            <a:r>
+              <a:rPr sz="1700" b="0" i="0">
                 <a:solidFill>
                   <a:srgbClr val="2A2929"/>
                 </a:solidFill>
                 <a:latin typeface="Roboto"/>
               </a:rPr>
-              <a:t>Kangan </a:t>
-            </a:r>
-            <a:r>
-              <a:rPr sz="1100" b="1" i="0">
-                <a:solidFill>
-                  <a:srgbClr val="D68E10"/>
-                </a:solidFill>
-                <a:latin typeface="Roboto"/>
-              </a:rPr>
-              <a:t>Institute</a:t>
-            </a:r>
+              <a:t>Workbook — tasks 1, 2 and 3.</a:t>
+            </a:r>
+          </a:p>
+          <a:p>
+            <a:pPr marL="0" indent="0">
+              <a:lnSpc>
+                <a:spcPct val="105000"/>
+              </a:lnSpc>
+              <a:spcBef>
+                <a:spcPts val="0"/>
+              </a:spcBef>
+              <a:spcAft>
+                <a:spcPts val="1000"/>
+              </a:spcAft>
+            </a:pPr>
+            <a:r>
+              <a:rPr sz="1700" b="1" i="0">
+                <a:solidFill>
+                  <a:srgbClr val="EDAB0C"/>
+                </a:solidFill>
+                <a:latin typeface="Roboto"/>
+              </a:rPr>
+              <a:t>■  </a:t>
+            </a:r>
+            <a:r>
+              <a:rPr sz="1700" b="0" i="0">
+                <a:solidFill>
+                  <a:srgbClr val="2A2929"/>
+                </a:solidFill>
+                <a:latin typeface="Roboto"/>
+              </a:rPr>
+              <a:t>As the practice team: agree the objective, set what is expected of each member, and agree the accountability mechanisms.</a:t>
+            </a:r>
+          </a:p>
+        </p:txBody>
+      </p:sp>
+      <p:sp>
+        <p:nvSpPr>
+          <p:cNvPr id="6" name="Rounded Rectangle 5"/>
+          <p:cNvSpPr/>
+          <p:nvPr/>
+        </p:nvSpPr>
+        <p:spPr>
+          <a:xfrm>
+            <a:off x="640080" y="5897880"/>
+            <a:ext cx="4023360" cy="457200"/>
+          </a:xfrm>
+          <a:prstGeom prst="roundRect">
+            <a:avLst/>
+          </a:prstGeom>
+          <a:solidFill>
+            <a:srgbClr val="F9F9F9"/>
+          </a:solidFill>
+          <a:ln w="12700">
+            <a:solidFill>
+              <a:srgbClr val="CCCCCC"/>
+            </a:solidFill>
+          </a:ln>
+          <a:effectLst/>
+        </p:spPr>
+        <p:style>
+          <a:lnRef idx="1">
+            <a:schemeClr val="accent1"/>
+          </a:lnRef>
+          <a:fillRef idx="3">
+            <a:schemeClr val="accent1"/>
+          </a:fillRef>
+          <a:effectRef idx="2">
+            <a:schemeClr val="accent1"/>
+          </a:effectRef>
+          <a:fontRef idx="minor">
+            <a:schemeClr val="lt1"/>
+          </a:fontRef>
+        </p:style>
+        <p:txBody>
+          <a:bodyPr rtlCol="0" anchor="ctr"/>
+          <a:lstStyle/>
+          <a:p>
+            <a:pPr algn="ctr"/>
           </a:p>
         </p:txBody>
       </p:sp>
@@ -10079,8 +9847,86 @@
         </p:nvSpPr>
         <p:spPr>
           <a:xfrm>
-            <a:off x="10515600" y="6400800"/>
-            <a:ext cx="1188720" cy="320040"/>
+            <a:off x="822960" y="5943600"/>
+            <a:ext cx="3657600" cy="365760"/>
+          </a:xfrm>
+          <a:prstGeom prst="rect">
+            <a:avLst/>
+          </a:prstGeom>
+          <a:noFill/>
+        </p:spPr>
+        <p:txBody>
+          <a:bodyPr wrap="square" anchor="ctr" lIns="0" rIns="0" tIns="0" bIns="0">
+            <a:spAutoFit/>
+          </a:bodyPr>
+          <a:lstStyle/>
+          <a:p>
+            <a:r>
+              <a:rPr sz="1500" b="1" i="0">
+                <a:solidFill>
+                  <a:srgbClr val="2A2929"/>
+                </a:solidFill>
+                <a:latin typeface="Roboto"/>
+              </a:rPr>
+              <a:t>⏱  ~35 min</a:t>
+            </a:r>
+          </a:p>
+        </p:txBody>
+      </p:sp>
+      <p:sp>
+        <p:nvSpPr>
+          <p:cNvPr id="8" name="Rectangle 7"/>
+          <p:cNvSpPr/>
+          <p:nvPr/>
+        </p:nvSpPr>
+        <p:spPr>
+          <a:xfrm>
+            <a:off x="0" y="6565392"/>
+            <a:ext cx="12191695" cy="38100"/>
+          </a:xfrm>
+          <a:prstGeom prst="rect">
+            <a:avLst/>
+          </a:prstGeom>
+          <a:solidFill>
+            <a:srgbClr val="92268F"/>
+          </a:solidFill>
+          <a:ln>
+            <a:noFill/>
+          </a:ln>
+          <a:effectLst/>
+        </p:spPr>
+        <p:style>
+          <a:lnRef idx="1">
+            <a:schemeClr val="accent1"/>
+          </a:lnRef>
+          <a:fillRef idx="3">
+            <a:schemeClr val="accent1"/>
+          </a:fillRef>
+          <a:effectRef idx="2">
+            <a:schemeClr val="accent1"/>
+          </a:effectRef>
+          <a:fontRef idx="minor">
+            <a:schemeClr val="lt1"/>
+          </a:fontRef>
+        </p:style>
+        <p:txBody>
+          <a:bodyPr rtlCol="0" anchor="ctr"/>
+          <a:lstStyle/>
+          <a:p>
+            <a:pPr algn="ctr"/>
+          </a:p>
+        </p:txBody>
+      </p:sp>
+      <p:sp>
+        <p:nvSpPr>
+          <p:cNvPr id="9" name="TextBox 8"/>
+          <p:cNvSpPr txBox="1"/>
+          <p:nvPr/>
+        </p:nvSpPr>
+        <p:spPr>
+          <a:xfrm>
+            <a:off x="502920" y="6400800"/>
+            <a:ext cx="5486400" cy="320040"/>
           </a:xfrm>
           <a:prstGeom prst="rect">
             <a:avLst/>
@@ -10093,6 +9939,49 @@
           </a:bodyPr>
           <a:lstStyle/>
           <a:p>
+            <a:r>
+              <a:rPr sz="1100" b="1" i="0">
+                <a:solidFill>
+                  <a:srgbClr val="2A2929"/>
+                </a:solidFill>
+                <a:latin typeface="Roboto"/>
+              </a:rPr>
+              <a:t>Kangan </a:t>
+            </a:r>
+            <a:r>
+              <a:rPr sz="1100" b="1" i="0">
+                <a:solidFill>
+                  <a:srgbClr val="D68E10"/>
+                </a:solidFill>
+                <a:latin typeface="Roboto"/>
+              </a:rPr>
+              <a:t>Institute</a:t>
+            </a:r>
+          </a:p>
+        </p:txBody>
+      </p:sp>
+      <p:sp>
+        <p:nvSpPr>
+          <p:cNvPr id="10" name="TextBox 9"/>
+          <p:cNvSpPr txBox="1"/>
+          <p:nvPr/>
+        </p:nvSpPr>
+        <p:spPr>
+          <a:xfrm>
+            <a:off x="10515600" y="6400800"/>
+            <a:ext cx="1188720" cy="320040"/>
+          </a:xfrm>
+          <a:prstGeom prst="rect">
+            <a:avLst/>
+          </a:prstGeom>
+          <a:noFill/>
+        </p:spPr>
+        <p:txBody>
+          <a:bodyPr wrap="square" anchor="t" lIns="0" rIns="0" tIns="0" bIns="0">
+            <a:spAutoFit/>
+          </a:bodyPr>
+          <a:lstStyle/>
+          <a:p>
             <a:pPr algn="r"/>
             <a:r>
               <a:rPr sz="1100" b="0" i="0">
@@ -10101,7 +9990,7 @@
                 </a:solidFill>
                 <a:latin typeface="Roboto"/>
               </a:rPr>
-              <a:t/>
+              <a:t>5</a:t>
             </a:r>
           </a:p>
         </p:txBody>
@@ -10120,7 +10009,7 @@
     <p:bg>
       <p:bgPr>
         <a:solidFill>
-          <a:srgbClr val="FFFFFF"/>
+          <a:srgbClr val="F9F9F9"/>
         </a:solidFill>
         <a:effectLst/>
       </p:bgPr>
@@ -10140,8 +10029,8 @@
         </p:nvSpPr>
         <p:spPr>
           <a:xfrm>
-            <a:off x="640080" y="457200"/>
-            <a:ext cx="10881360" cy="960120"/>
+            <a:off x="640080" y="548640"/>
+            <a:ext cx="10881360" cy="1097280"/>
           </a:xfrm>
           <a:prstGeom prst="rect">
             <a:avLst/>
@@ -10155,13 +10044,29 @@
           <a:lstStyle/>
           <a:p>
             <a:r>
-              <a:rPr sz="2800" b="1" i="0">
+              <a:rPr sz="3200" b="1" i="0">
                 <a:solidFill>
                   <a:srgbClr val="2A2929"/>
                 </a:solidFill>
                 <a:latin typeface="Roboto"/>
               </a:rPr>
-              <a:t>Typical team contingencies</a:t>
+              <a:t>Key takeaways</a:t>
+            </a:r>
+          </a:p>
+          <a:p>
+            <a:pPr>
+              <a:spcBef>
+                <a:spcPts val="200"/>
+              </a:spcBef>
+            </a:pPr>
+            <a:r>
+              <a:rPr sz="1800" b="1" i="0">
+                <a:solidFill>
+                  <a:srgbClr val="92268F"/>
+                </a:solidFill>
+                <a:latin typeface="Roboto"/>
+              </a:rPr>
+              <a:t>Section 1 · The set-up</a:t>
             </a:r>
           </a:p>
         </p:txBody>
@@ -10174,14 +10079,14 @@
         </p:nvSpPr>
         <p:spPr>
           <a:xfrm>
-            <a:off x="658368" y="1371600"/>
+            <a:off x="658368" y="1600200"/>
             <a:ext cx="1463040" cy="50800"/>
           </a:xfrm>
           <a:prstGeom prst="rect">
             <a:avLst/>
           </a:prstGeom>
           <a:solidFill>
-            <a:srgbClr val="27B5CE"/>
+            <a:srgbClr val="92268F"/>
           </a:solidFill>
           <a:ln>
             <a:noFill/>
@@ -10212,148 +10117,47 @@
       </p:sp>
       <p:sp>
         <p:nvSpPr>
-          <p:cNvPr id="4" name="TextBox 3"/>
-          <p:cNvSpPr txBox="1"/>
-          <p:nvPr/>
-        </p:nvSpPr>
-        <p:spPr>
-          <a:xfrm>
-            <a:off x="658368" y="1691640"/>
-            <a:ext cx="10881360" cy="4480560"/>
-          </a:xfrm>
-          <a:prstGeom prst="rect">
-            <a:avLst/>
-          </a:prstGeom>
-          <a:noFill/>
-        </p:spPr>
-        <p:txBody>
-          <a:bodyPr wrap="square" anchor="ctr" lIns="0" rIns="0" tIns="0" bIns="0">
-            <a:spAutoFit/>
-          </a:bodyPr>
-          <a:lstStyle/>
-          <a:p>
-            <a:pPr marL="0" indent="0">
-              <a:lnSpc>
-                <a:spcPct val="105000"/>
-              </a:lnSpc>
-              <a:spcBef>
-                <a:spcPts val="0"/>
-              </a:spcBef>
-              <a:spcAft>
-                <a:spcPts val="1000"/>
-              </a:spcAft>
-            </a:pPr>
-            <a:r>
-              <a:rPr sz="2400" b="1" i="0">
-                <a:solidFill>
-                  <a:srgbClr val="EDAB0C"/>
-                </a:solidFill>
-                <a:latin typeface="Roboto"/>
-              </a:rPr>
-              <a:t>■  </a:t>
-            </a:r>
-            <a:r>
-              <a:rPr sz="2400" b="0" i="0">
-                <a:solidFill>
-                  <a:srgbClr val="2A2929"/>
-                </a:solidFill>
-                <a:latin typeface="Roboto"/>
-              </a:rPr>
-              <a:t>Plan for contingencies that could impact the team before they happen — don't improvise under pressure.</a:t>
-            </a:r>
-          </a:p>
-          <a:p>
-            <a:pPr marL="0" indent="0">
-              <a:lnSpc>
-                <a:spcPct val="105000"/>
-              </a:lnSpc>
-              <a:spcBef>
-                <a:spcPts val="0"/>
-              </a:spcBef>
-              <a:spcAft>
-                <a:spcPts val="1000"/>
-              </a:spcAft>
-            </a:pPr>
-            <a:r>
-              <a:rPr sz="2400" b="1" i="0">
-                <a:solidFill>
-                  <a:srgbClr val="EDAB0C"/>
-                </a:solidFill>
-                <a:latin typeface="Roboto"/>
-              </a:rPr>
-              <a:t>■  </a:t>
-            </a:r>
-            <a:r>
-              <a:rPr sz="2400" b="0" i="0">
-                <a:solidFill>
-                  <a:srgbClr val="2A2929"/>
-                </a:solidFill>
-                <a:latin typeface="Roboto"/>
-              </a:rPr>
-              <a:t>The typical workplace ones: unplanned leave or absence of a component owner; re-allocation of work tasks when load shifts; succession planning for important roles (KE 9).</a:t>
-            </a:r>
-          </a:p>
-          <a:p>
-            <a:pPr marL="0" indent="0">
-              <a:lnSpc>
-                <a:spcPct val="105000"/>
-              </a:lnSpc>
-              <a:spcBef>
-                <a:spcPts val="0"/>
-              </a:spcBef>
-              <a:spcAft>
-                <a:spcPts val="1000"/>
-              </a:spcAft>
-            </a:pPr>
-            <a:r>
-              <a:rPr sz="2400" b="1" i="0">
-                <a:solidFill>
-                  <a:srgbClr val="EDAB0C"/>
-                </a:solidFill>
-                <a:latin typeface="Roboto"/>
-              </a:rPr>
-              <a:t>■  </a:t>
-            </a:r>
-            <a:r>
-              <a:rPr sz="2400" b="0" i="0">
-                <a:solidFill>
-                  <a:srgbClr val="2A2929"/>
-                </a:solidFill>
-                <a:latin typeface="Roboto"/>
-              </a:rPr>
-              <a:t>For the build team: if the database-component owner is absent, who picks it up, and how is the handover documented?</a:t>
-            </a:r>
-          </a:p>
-          <a:p>
-            <a:pPr marL="0" indent="0">
-              <a:lnSpc>
-                <a:spcPct val="105000"/>
-              </a:lnSpc>
-              <a:spcBef>
-                <a:spcPts val="0"/>
-              </a:spcBef>
-              <a:spcAft>
-                <a:spcPts val="1000"/>
-              </a:spcAft>
-            </a:pPr>
-            <a:r>
-              <a:rPr sz="2400" b="1" i="0">
-                <a:solidFill>
-                  <a:srgbClr val="EDAB0C"/>
-                </a:solidFill>
-                <a:latin typeface="Roboto"/>
-              </a:rPr>
-              <a:t>■  </a:t>
-            </a:r>
-            <a:r>
-              <a:rPr sz="2400" b="0" i="0">
-                <a:solidFill>
-                  <a:srgbClr val="2A2929"/>
-                </a:solidFill>
-                <a:latin typeface="Roboto"/>
-              </a:rPr>
-              <a:t>A contingency is a named trigger plus a pre-agreed response — write it into the team plan.</a:t>
-            </a:r>
+          <p:cNvPr id="4" name="Rectangle 3"/>
+          <p:cNvSpPr/>
+          <p:nvPr/>
+        </p:nvSpPr>
+        <p:spPr>
+          <a:xfrm>
+            <a:off x="640080" y="1965960"/>
+            <a:ext cx="10927080" cy="841248"/>
+          </a:xfrm>
+          <a:prstGeom prst="rect">
+            <a:avLst/>
+          </a:prstGeom>
+          <a:solidFill>
+            <a:srgbClr val="FFFFFF"/>
+          </a:solidFill>
+          <a:ln w="12700">
+            <a:solidFill>
+              <a:srgbClr val="CCCCCC"/>
+            </a:solidFill>
+          </a:ln>
+          <a:effectLst/>
+        </p:spPr>
+        <p:style>
+          <a:lnRef idx="1">
+            <a:schemeClr val="accent1"/>
+          </a:lnRef>
+          <a:fillRef idx="3">
+            <a:schemeClr val="accent1"/>
+          </a:fillRef>
+          <a:effectRef idx="2">
+            <a:schemeClr val="accent1"/>
+          </a:effectRef>
+          <a:fontRef idx="minor">
+            <a:schemeClr val="lt1"/>
+          </a:fontRef>
+        </p:style>
+        <p:txBody>
+          <a:bodyPr rtlCol="0" anchor="ctr"/>
+          <a:lstStyle/>
+          <a:p>
+            <a:pPr algn="ctr"/>
           </a:p>
         </p:txBody>
       </p:sp>
@@ -10365,14 +10169,14 @@
         </p:nvSpPr>
         <p:spPr>
           <a:xfrm>
-            <a:off x="0" y="6565392"/>
-            <a:ext cx="12191695" cy="38100"/>
+            <a:off x="640080" y="1965960"/>
+            <a:ext cx="109728" cy="841248"/>
           </a:xfrm>
           <a:prstGeom prst="rect">
             <a:avLst/>
           </a:prstGeom>
           <a:solidFill>
-            <a:srgbClr val="27B5CE"/>
+            <a:srgbClr val="92268F"/>
           </a:solidFill>
           <a:ln>
             <a:noFill/>
@@ -10409,6 +10213,347 @@
         </p:nvSpPr>
         <p:spPr>
           <a:xfrm>
+            <a:off x="960120" y="1965960"/>
+            <a:ext cx="10424160" cy="841248"/>
+          </a:xfrm>
+          <a:prstGeom prst="rect">
+            <a:avLst/>
+          </a:prstGeom>
+          <a:noFill/>
+        </p:spPr>
+        <p:txBody>
+          <a:bodyPr wrap="square" anchor="ctr" lIns="0" rIns="0" tIns="0" bIns="0">
+            <a:spAutoFit/>
+          </a:bodyPr>
+          <a:lstStyle/>
+          <a:p>
+            <a:pPr>
+              <a:lnSpc>
+                <a:spcPct val="100000"/>
+              </a:lnSpc>
+            </a:pPr>
+            <a:r>
+              <a:rPr sz="1700" b="0" i="0">
+                <a:solidFill>
+                  <a:srgbClr val="2A2929"/>
+                </a:solidFill>
+                <a:latin typeface="Roboto"/>
+              </a:rPr>
+              <a:t>One objective, recitable by all.</a:t>
+            </a:r>
+          </a:p>
+        </p:txBody>
+      </p:sp>
+      <p:sp>
+        <p:nvSpPr>
+          <p:cNvPr id="7" name="Rectangle 6"/>
+          <p:cNvSpPr/>
+          <p:nvPr/>
+        </p:nvSpPr>
+        <p:spPr>
+          <a:xfrm>
+            <a:off x="640080" y="2916936"/>
+            <a:ext cx="10927080" cy="841248"/>
+          </a:xfrm>
+          <a:prstGeom prst="rect">
+            <a:avLst/>
+          </a:prstGeom>
+          <a:solidFill>
+            <a:srgbClr val="FFFFFF"/>
+          </a:solidFill>
+          <a:ln w="12700">
+            <a:solidFill>
+              <a:srgbClr val="CCCCCC"/>
+            </a:solidFill>
+          </a:ln>
+          <a:effectLst/>
+        </p:spPr>
+        <p:style>
+          <a:lnRef idx="1">
+            <a:schemeClr val="accent1"/>
+          </a:lnRef>
+          <a:fillRef idx="3">
+            <a:schemeClr val="accent1"/>
+          </a:fillRef>
+          <a:effectRef idx="2">
+            <a:schemeClr val="accent1"/>
+          </a:effectRef>
+          <a:fontRef idx="minor">
+            <a:schemeClr val="lt1"/>
+          </a:fontRef>
+        </p:style>
+        <p:txBody>
+          <a:bodyPr rtlCol="0" anchor="ctr"/>
+          <a:lstStyle/>
+          <a:p>
+            <a:pPr algn="ctr"/>
+          </a:p>
+        </p:txBody>
+      </p:sp>
+      <p:sp>
+        <p:nvSpPr>
+          <p:cNvPr id="8" name="Rectangle 7"/>
+          <p:cNvSpPr/>
+          <p:nvPr/>
+        </p:nvSpPr>
+        <p:spPr>
+          <a:xfrm>
+            <a:off x="640080" y="2916936"/>
+            <a:ext cx="109728" cy="841248"/>
+          </a:xfrm>
+          <a:prstGeom prst="rect">
+            <a:avLst/>
+          </a:prstGeom>
+          <a:solidFill>
+            <a:srgbClr val="92268F"/>
+          </a:solidFill>
+          <a:ln>
+            <a:noFill/>
+          </a:ln>
+          <a:effectLst/>
+        </p:spPr>
+        <p:style>
+          <a:lnRef idx="1">
+            <a:schemeClr val="accent1"/>
+          </a:lnRef>
+          <a:fillRef idx="3">
+            <a:schemeClr val="accent1"/>
+          </a:fillRef>
+          <a:effectRef idx="2">
+            <a:schemeClr val="accent1"/>
+          </a:effectRef>
+          <a:fontRef idx="minor">
+            <a:schemeClr val="lt1"/>
+          </a:fontRef>
+        </p:style>
+        <p:txBody>
+          <a:bodyPr rtlCol="0" anchor="ctr"/>
+          <a:lstStyle/>
+          <a:p>
+            <a:pPr algn="ctr"/>
+          </a:p>
+        </p:txBody>
+      </p:sp>
+      <p:sp>
+        <p:nvSpPr>
+          <p:cNvPr id="9" name="TextBox 8"/>
+          <p:cNvSpPr txBox="1"/>
+          <p:nvPr/>
+        </p:nvSpPr>
+        <p:spPr>
+          <a:xfrm>
+            <a:off x="960120" y="2916936"/>
+            <a:ext cx="10424160" cy="841248"/>
+          </a:xfrm>
+          <a:prstGeom prst="rect">
+            <a:avLst/>
+          </a:prstGeom>
+          <a:noFill/>
+        </p:spPr>
+        <p:txBody>
+          <a:bodyPr wrap="square" anchor="ctr" lIns="0" rIns="0" tIns="0" bIns="0">
+            <a:spAutoFit/>
+          </a:bodyPr>
+          <a:lstStyle/>
+          <a:p>
+            <a:pPr>
+              <a:lnSpc>
+                <a:spcPct val="100000"/>
+              </a:lnSpc>
+            </a:pPr>
+            <a:r>
+              <a:rPr sz="1700" b="0" i="0">
+                <a:solidFill>
+                  <a:srgbClr val="2A2929"/>
+                </a:solidFill>
+                <a:latin typeface="Roboto"/>
+              </a:rPr>
+              <a:t>Measurable expectations per member.</a:t>
+            </a:r>
+          </a:p>
+        </p:txBody>
+      </p:sp>
+      <p:sp>
+        <p:nvSpPr>
+          <p:cNvPr id="10" name="Rectangle 9"/>
+          <p:cNvSpPr/>
+          <p:nvPr/>
+        </p:nvSpPr>
+        <p:spPr>
+          <a:xfrm>
+            <a:off x="640080" y="3867912"/>
+            <a:ext cx="10927080" cy="841248"/>
+          </a:xfrm>
+          <a:prstGeom prst="rect">
+            <a:avLst/>
+          </a:prstGeom>
+          <a:solidFill>
+            <a:srgbClr val="FFFFFF"/>
+          </a:solidFill>
+          <a:ln w="12700">
+            <a:solidFill>
+              <a:srgbClr val="CCCCCC"/>
+            </a:solidFill>
+          </a:ln>
+          <a:effectLst/>
+        </p:spPr>
+        <p:style>
+          <a:lnRef idx="1">
+            <a:schemeClr val="accent1"/>
+          </a:lnRef>
+          <a:fillRef idx="3">
+            <a:schemeClr val="accent1"/>
+          </a:fillRef>
+          <a:effectRef idx="2">
+            <a:schemeClr val="accent1"/>
+          </a:effectRef>
+          <a:fontRef idx="minor">
+            <a:schemeClr val="lt1"/>
+          </a:fontRef>
+        </p:style>
+        <p:txBody>
+          <a:bodyPr rtlCol="0" anchor="ctr"/>
+          <a:lstStyle/>
+          <a:p>
+            <a:pPr algn="ctr"/>
+          </a:p>
+        </p:txBody>
+      </p:sp>
+      <p:sp>
+        <p:nvSpPr>
+          <p:cNvPr id="11" name="Rectangle 10"/>
+          <p:cNvSpPr/>
+          <p:nvPr/>
+        </p:nvSpPr>
+        <p:spPr>
+          <a:xfrm>
+            <a:off x="640080" y="3867912"/>
+            <a:ext cx="109728" cy="841248"/>
+          </a:xfrm>
+          <a:prstGeom prst="rect">
+            <a:avLst/>
+          </a:prstGeom>
+          <a:solidFill>
+            <a:srgbClr val="92268F"/>
+          </a:solidFill>
+          <a:ln>
+            <a:noFill/>
+          </a:ln>
+          <a:effectLst/>
+        </p:spPr>
+        <p:style>
+          <a:lnRef idx="1">
+            <a:schemeClr val="accent1"/>
+          </a:lnRef>
+          <a:fillRef idx="3">
+            <a:schemeClr val="accent1"/>
+          </a:fillRef>
+          <a:effectRef idx="2">
+            <a:schemeClr val="accent1"/>
+          </a:effectRef>
+          <a:fontRef idx="minor">
+            <a:schemeClr val="lt1"/>
+          </a:fontRef>
+        </p:style>
+        <p:txBody>
+          <a:bodyPr rtlCol="0" anchor="ctr"/>
+          <a:lstStyle/>
+          <a:p>
+            <a:pPr algn="ctr"/>
+          </a:p>
+        </p:txBody>
+      </p:sp>
+      <p:sp>
+        <p:nvSpPr>
+          <p:cNvPr id="12" name="TextBox 11"/>
+          <p:cNvSpPr txBox="1"/>
+          <p:nvPr/>
+        </p:nvSpPr>
+        <p:spPr>
+          <a:xfrm>
+            <a:off x="960120" y="3867912"/>
+            <a:ext cx="10424160" cy="841248"/>
+          </a:xfrm>
+          <a:prstGeom prst="rect">
+            <a:avLst/>
+          </a:prstGeom>
+          <a:noFill/>
+        </p:spPr>
+        <p:txBody>
+          <a:bodyPr wrap="square" anchor="ctr" lIns="0" rIns="0" tIns="0" bIns="0">
+            <a:spAutoFit/>
+          </a:bodyPr>
+          <a:lstStyle/>
+          <a:p>
+            <a:pPr>
+              <a:lnSpc>
+                <a:spcPct val="100000"/>
+              </a:lnSpc>
+            </a:pPr>
+            <a:r>
+              <a:rPr sz="1700" b="0" i="0">
+                <a:solidFill>
+                  <a:srgbClr val="2A2929"/>
+                </a:solidFill>
+                <a:latin typeface="Roboto"/>
+              </a:rPr>
+              <a:t>Accountability grounded in policy and law.</a:t>
+            </a:r>
+          </a:p>
+        </p:txBody>
+      </p:sp>
+      <p:sp>
+        <p:nvSpPr>
+          <p:cNvPr id="13" name="Rectangle 12"/>
+          <p:cNvSpPr/>
+          <p:nvPr/>
+        </p:nvSpPr>
+        <p:spPr>
+          <a:xfrm>
+            <a:off x="0" y="6565392"/>
+            <a:ext cx="12191695" cy="38100"/>
+          </a:xfrm>
+          <a:prstGeom prst="rect">
+            <a:avLst/>
+          </a:prstGeom>
+          <a:solidFill>
+            <a:srgbClr val="92268F"/>
+          </a:solidFill>
+          <a:ln>
+            <a:noFill/>
+          </a:ln>
+          <a:effectLst/>
+        </p:spPr>
+        <p:style>
+          <a:lnRef idx="1">
+            <a:schemeClr val="accent1"/>
+          </a:lnRef>
+          <a:fillRef idx="3">
+            <a:schemeClr val="accent1"/>
+          </a:fillRef>
+          <a:effectRef idx="2">
+            <a:schemeClr val="accent1"/>
+          </a:effectRef>
+          <a:fontRef idx="minor">
+            <a:schemeClr val="lt1"/>
+          </a:fontRef>
+        </p:style>
+        <p:txBody>
+          <a:bodyPr rtlCol="0" anchor="ctr"/>
+          <a:lstStyle/>
+          <a:p>
+            <a:pPr algn="ctr"/>
+          </a:p>
+        </p:txBody>
+      </p:sp>
+      <p:sp>
+        <p:nvSpPr>
+          <p:cNvPr id="14" name="TextBox 13"/>
+          <p:cNvSpPr txBox="1"/>
+          <p:nvPr/>
+        </p:nvSpPr>
+        <p:spPr>
+          <a:xfrm>
             <a:off x="502920" y="6400800"/>
             <a:ext cx="5486400" cy="320040"/>
           </a:xfrm>
@@ -10446,7 +10591,7 @@
       </p:sp>
       <p:sp>
         <p:nvSpPr>
-          <p:cNvPr id="7" name="TextBox 6"/>
+          <p:cNvPr id="15" name="TextBox 14"/>
           <p:cNvSpPr txBox="1"/>
           <p:nvPr/>
         </p:nvSpPr>
@@ -10474,7 +10619,7 @@
                 </a:solidFill>
                 <a:latin typeface="Roboto"/>
               </a:rPr>
-              <a:t>5</a:t>
+              <a:t>6</a:t>
             </a:r>
           </a:p>
         </p:txBody>
@@ -10520,7 +10665,7 @@
             <a:avLst/>
           </a:prstGeom>
           <a:solidFill>
-            <a:srgbClr val="205F61"/>
+            <a:srgbClr val="27B5CE"/>
           </a:solidFill>
           <a:ln>
             <a:noFill/>
@@ -10578,7 +10723,7 @@
                 </a:solidFill>
                 <a:latin typeface="Roboto"/>
               </a:rPr>
-              <a:t>03</a:t>
+              <a:t>02</a:t>
             </a:r>
           </a:p>
         </p:txBody>
@@ -10608,7 +10753,7 @@
             <a:r>
               <a:rPr sz="1600" b="1" i="0">
                 <a:solidFill>
-                  <a:srgbClr val="205F61"/>
+                  <a:srgbClr val="27B5CE"/>
                 </a:solidFill>
                 <a:latin typeface="Roboto"/>
               </a:rPr>
@@ -10628,7 +10773,7 @@
                 </a:solidFill>
                 <a:latin typeface="Roboto"/>
               </a:rPr>
-              <a:t>Communicating &amp; allocating the component work</a:t>
+              <a:t>Plan for what could go wrong</a:t>
             </a:r>
           </a:p>
           <a:p>
@@ -10644,7 +10789,7 @@
                 </a:solidFill>
                 <a:latin typeface="Roboto Light"/>
               </a:rPr>
-              <a:t>communicate the goal, then hand out the work</a:t>
+              <a:t>decide the response while calm</a:t>
             </a:r>
           </a:p>
         </p:txBody>
@@ -10664,7 +10809,7 @@
             <a:avLst/>
           </a:prstGeom>
           <a:solidFill>
-            <a:srgbClr val="205F61"/>
+            <a:srgbClr val="27B5CE"/>
           </a:solidFill>
           <a:ln>
             <a:noFill/>

</xml_diff>